<commit_message>
fix: remove SIH branding and fix text overflow on slide 3
</commit_message>
<xml_diff>
--- a/SIH2024_GTU_Alert_System_Presentation.pptx
+++ b/SIH2024_GTU_Alert_System_Presentation.pptx
@@ -3249,14 +3249,14 @@
           <a:lstStyle/>
           <a:p>
             <a:pPr>
-              <a:defRPr sz="1300" b="1">
+              <a:defRPr sz="1250" b="1">
                 <a:solidFill>
                   <a:srgbClr val="F97316"/>
                 </a:solidFill>
               </a:defRPr>
             </a:pPr>
             <a:r>
-              <a:t>SMART INDIA HACKATHON 2024  |  INTERNAL &amp; NATIONAL LEVEL EVALUATION</a:t>
+              <a:t>FINAL YEAR CAPSTONE PROJECT DEFENSE  |  ACADEMIC PRESENTATION</a:t>
             </a:r>
           </a:p>
         </p:txBody>
@@ -3365,7 +3365,7 @@
         <p:spPr>
           <a:xfrm>
             <a:off x="594360" y="2148840"/>
-            <a:ext cx="2578608" cy="530352"/>
+            <a:ext cx="2578608" cy="475488"/>
           </a:xfrm>
           <a:prstGeom prst="roundRect">
             <a:avLst/>
@@ -3407,8 +3407,8 @@
         </p:nvSpPr>
         <p:spPr>
           <a:xfrm>
-            <a:off x="777240" y="2203704"/>
-            <a:ext cx="2212848" cy="457200"/>
+            <a:off x="758952" y="2194560"/>
+            <a:ext cx="2249424" cy="402336"/>
           </a:xfrm>
           <a:prstGeom prst="rect">
             <a:avLst/>
@@ -3422,14 +3422,14 @@
           <a:lstStyle/>
           <a:p>
             <a:pPr>
-              <a:defRPr sz="1550" b="1">
+              <a:defRPr sz="1450" b="1">
                 <a:solidFill>
                   <a:srgbClr val="FFFFFF"/>
                 </a:solidFill>
               </a:defRPr>
             </a:pPr>
             <a:r>
-              <a:t>Problem Statement</a:t>
+              <a:t>Project Overview</a:t>
             </a:r>
           </a:p>
         </p:txBody>
@@ -3442,8 +3442,8 @@
         </p:nvSpPr>
         <p:spPr>
           <a:xfrm>
-            <a:off x="777240" y="2788920"/>
-            <a:ext cx="2212848" cy="3493008"/>
+            <a:off x="758952" y="2697480"/>
+            <a:ext cx="2249424" cy="3602736"/>
           </a:xfrm>
           <a:prstGeom prst="rect">
             <a:avLst/>
@@ -3467,7 +3467,7 @@
               </a:defRPr>
             </a:pPr>
             <a:r>
-              <a:t>•  Problem ID: SIH-EDU-042</a:t>
+              <a:t>•  Project Type: Full-Stack &amp; Cloud System</a:t>
             </a:r>
           </a:p>
           <a:p>
@@ -3482,7 +3482,7 @@
               </a:defRPr>
             </a:pPr>
             <a:r>
-              <a:t>•  Category: Software Edition</a:t>
+              <a:t>•  Domain: University Automation &amp; NLP</a:t>
             </a:r>
           </a:p>
           <a:p>
@@ -3497,7 +3497,7 @@
               </a:defRPr>
             </a:pPr>
             <a:r>
-              <a:t>•  Theme: Smart Education &amp; Campus Automation</a:t>
+              <a:t>•  Focus: Student Welfare &amp; Notification AI</a:t>
             </a:r>
           </a:p>
           <a:p>
@@ -3512,7 +3512,7 @@
               </a:defRPr>
             </a:pPr>
             <a:r>
-              <a:t>•  Domain: University Administration &amp; Student Welfare</a:t>
+              <a:t>•  Target Base: 4,00,000+ GTU Students</a:t>
             </a:r>
           </a:p>
           <a:p>
@@ -3527,7 +3527,7 @@
               </a:defRPr>
             </a:pPr>
             <a:r>
-              <a:t>•  Target Audience: 4,00,000+ GTU Students across 400+ Colleges</a:t>
+              <a:t>•  Coverage: 400+ Affiliated Engineering, Pharmacy &amp; Management Colleges</a:t>
             </a:r>
           </a:p>
         </p:txBody>
@@ -3586,7 +3586,7 @@
         <p:spPr>
           <a:xfrm>
             <a:off x="3392424" y="2148840"/>
-            <a:ext cx="2578608" cy="530352"/>
+            <a:ext cx="2578608" cy="475488"/>
           </a:xfrm>
           <a:prstGeom prst="roundRect">
             <a:avLst/>
@@ -3628,8 +3628,8 @@
         </p:nvSpPr>
         <p:spPr>
           <a:xfrm>
-            <a:off x="3575304" y="2203704"/>
-            <a:ext cx="2212848" cy="457200"/>
+            <a:off x="3557016" y="2194560"/>
+            <a:ext cx="2249424" cy="402336"/>
           </a:xfrm>
           <a:prstGeom prst="rect">
             <a:avLst/>
@@ -3643,14 +3643,14 @@
           <a:lstStyle/>
           <a:p>
             <a:pPr>
-              <a:defRPr sz="1550" b="1">
+              <a:defRPr sz="1450" b="1">
                 <a:solidFill>
                   <a:srgbClr val="FFFFFF"/>
                 </a:solidFill>
               </a:defRPr>
             </a:pPr>
             <a:r>
-              <a:t>The Innovation</a:t>
+              <a:t>Key Innovations</a:t>
             </a:r>
           </a:p>
         </p:txBody>
@@ -3663,8 +3663,8 @@
         </p:nvSpPr>
         <p:spPr>
           <a:xfrm>
-            <a:off x="3575304" y="2788920"/>
-            <a:ext cx="2212848" cy="3493008"/>
+            <a:off x="3557016" y="2697480"/>
+            <a:ext cx="2249424" cy="3602736"/>
           </a:xfrm>
           <a:prstGeom prst="rect">
             <a:avLst/>
@@ -3688,7 +3688,7 @@
               </a:defRPr>
             </a:pPr>
             <a:r>
-              <a:t>•  Zero-latency automated polling of official GTU portal.</a:t>
+              <a:t>•  Zero-latency automated polling of GTU portal.</a:t>
             </a:r>
           </a:p>
           <a:p>
@@ -3703,7 +3703,7 @@
               </a:defRPr>
             </a:pPr>
             <a:r>
-              <a:t>•  Regex NLP automatically tags stream, sem &amp; exam type.</a:t>
+              <a:t>•  Regex NLP automatically tags stream, sem &amp; exam.</a:t>
             </a:r>
           </a:p>
           <a:p>
@@ -3718,7 +3718,7 @@
               </a:defRPr>
             </a:pPr>
             <a:r>
-              <a:t>•  Penalty fee &amp; deadline extractor flag urgent notices.</a:t>
+              <a:t>•  Penalty fee &amp; deadline extractor flag urgent alerts.</a:t>
             </a:r>
           </a:p>
           <a:p>
@@ -3748,7 +3748,7 @@
               </a:defRPr>
             </a:pPr>
             <a:r>
-              <a:t>•  AI Summarizer delivers 1-sentence instant takeaways.</a:t>
+              <a:t>•  Gemini AI delivers 1-sentence instant takeaways.</a:t>
             </a:r>
           </a:p>
         </p:txBody>
@@ -3807,7 +3807,7 @@
         <p:spPr>
           <a:xfrm>
             <a:off x="6190488" y="2148840"/>
-            <a:ext cx="2578608" cy="530352"/>
+            <a:ext cx="2578608" cy="475488"/>
           </a:xfrm>
           <a:prstGeom prst="roundRect">
             <a:avLst/>
@@ -3849,8 +3849,8 @@
         </p:nvSpPr>
         <p:spPr>
           <a:xfrm>
-            <a:off x="6373368" y="2203704"/>
-            <a:ext cx="2212848" cy="457200"/>
+            <a:off x="6355080" y="2194560"/>
+            <a:ext cx="2249424" cy="402336"/>
           </a:xfrm>
           <a:prstGeom prst="rect">
             <a:avLst/>
@@ -3864,7 +3864,7 @@
           <a:lstStyle/>
           <a:p>
             <a:pPr>
-              <a:defRPr sz="1550" b="1">
+              <a:defRPr sz="1450" b="1">
                 <a:solidFill>
                   <a:srgbClr val="FFFFFF"/>
                 </a:solidFill>
@@ -3884,8 +3884,8 @@
         </p:nvSpPr>
         <p:spPr>
           <a:xfrm>
-            <a:off x="6373368" y="2788920"/>
-            <a:ext cx="2212848" cy="3493008"/>
+            <a:off x="6355080" y="2697480"/>
+            <a:ext cx="2249424" cy="3602736"/>
           </a:xfrm>
           <a:prstGeom prst="rect">
             <a:avLst/>
@@ -3924,7 +3924,7 @@
               </a:defRPr>
             </a:pPr>
             <a:r>
-              <a:t>•  Web Parsing: BeautifulSoup4</a:t>
+              <a:t>•  Web Scraping: BeautifulSoup4 &amp; requests</a:t>
             </a:r>
           </a:p>
           <a:p>
@@ -3969,7 +3969,7 @@
               </a:defRPr>
             </a:pPr>
             <a:r>
-              <a:t>•  Frontend: Vanilla JS PWA (Offline Service Worker)</a:t>
+              <a:t>•  Frontend: Vanilla JS PWA (Offline Cache)</a:t>
             </a:r>
           </a:p>
           <a:p>
@@ -3984,7 +3984,7 @@
               </a:defRPr>
             </a:pPr>
             <a:r>
-              <a:t>•  Cloud: GitHub Actions (Zero Hosting Cost)</a:t>
+              <a:t>•  Automation: GitHub Actions (Zero Cost)</a:t>
             </a:r>
           </a:p>
         </p:txBody>
@@ -4043,7 +4043,7 @@
         <p:spPr>
           <a:xfrm>
             <a:off x="8988552" y="2148840"/>
-            <a:ext cx="2578608" cy="530352"/>
+            <a:ext cx="2578608" cy="475488"/>
           </a:xfrm>
           <a:prstGeom prst="roundRect">
             <a:avLst/>
@@ -4085,8 +4085,8 @@
         </p:nvSpPr>
         <p:spPr>
           <a:xfrm>
-            <a:off x="9171432" y="2203704"/>
-            <a:ext cx="2212848" cy="457200"/>
+            <a:off x="9153144" y="2194560"/>
+            <a:ext cx="2249424" cy="402336"/>
           </a:xfrm>
           <a:prstGeom prst="rect">
             <a:avLst/>
@@ -4100,7 +4100,7 @@
           <a:lstStyle/>
           <a:p>
             <a:pPr>
-              <a:defRPr sz="1550" b="1">
+              <a:defRPr sz="1450" b="1">
                 <a:solidFill>
                   <a:srgbClr val="FFFFFF"/>
                 </a:solidFill>
@@ -4120,8 +4120,8 @@
         </p:nvSpPr>
         <p:spPr>
           <a:xfrm>
-            <a:off x="9171432" y="2788920"/>
-            <a:ext cx="2212848" cy="3493008"/>
+            <a:off x="9153144" y="2697480"/>
+            <a:ext cx="2249424" cy="3602736"/>
           </a:xfrm>
           <a:prstGeom prst="rect">
             <a:avLst/>
@@ -4220,7 +4220,7 @@
               </a:defRPr>
             </a:pPr>
             <a:r>
-              <a:t>•  Faculty Mentor: [Guide / HOD Name]</a:t>
+              <a:t>•  Project Guide: [Faculty / Guide Name]</a:t>
             </a:r>
           </a:p>
         </p:txBody>
@@ -4380,8 +4380,8 @@
         </p:nvSpPr>
         <p:spPr>
           <a:xfrm>
-            <a:off x="7498079" y="164592"/>
-            <a:ext cx="4114800" cy="777240"/>
+            <a:off x="7132320" y="164592"/>
+            <a:ext cx="4480560" cy="777240"/>
           </a:xfrm>
           <a:prstGeom prst="rect">
             <a:avLst/>
@@ -4395,18 +4395,18 @@
           <a:lstStyle/>
           <a:p>
             <a:pPr algn="r">
-              <a:defRPr sz="1100" b="1">
+              <a:defRPr sz="1050" b="1">
                 <a:solidFill>
                   <a:srgbClr val="F97316"/>
                 </a:solidFill>
               </a:defRPr>
             </a:pPr>
             <a:r>
-              <a:t>SMART INDIA HACKATHON 2024</a:t>
+              <a:t>GUJARAT TECHNOLOGICAL UNIVERSITY</a:t>
             </a:r>
             <a:br/>
             <a:r>
-              <a:t>THEME: SMART EDUCATION / AUTOMATION</a:t>
+              <a:t>CAMPUS AUTOMATION &amp; STUDENT WELFARE</a:t>
             </a:r>
           </a:p>
         </p:txBody>
@@ -4420,7 +4420,7 @@
         <p:spPr>
           <a:xfrm>
             <a:off x="594360" y="201168"/>
-            <a:ext cx="6858000" cy="685800"/>
+            <a:ext cx="6583680" cy="685800"/>
           </a:xfrm>
           <a:prstGeom prst="rect">
             <a:avLst/>
@@ -4500,7 +4500,7 @@
         <p:spPr>
           <a:xfrm>
             <a:off x="594360" y="6510528"/>
-            <a:ext cx="7772400" cy="320040"/>
+            <a:ext cx="8046720" cy="320040"/>
           </a:xfrm>
           <a:prstGeom prst="rect">
             <a:avLst/>
@@ -4521,7 +4521,7 @@
               </a:defRPr>
             </a:pPr>
             <a:r>
-              <a:t>SIH 2024  |  Problem: GTU Notice Broadcast Automation  |  Team: GTU Innovators</a:t>
+              <a:t>GTU Circular &amp; Notification Alert System  |  Department of Computer / IT Engineering</a:t>
             </a:r>
           </a:p>
         </p:txBody>
@@ -4615,7 +4615,7 @@
         <p:spPr>
           <a:xfrm>
             <a:off x="594360" y="1234440"/>
-            <a:ext cx="5376672" cy="621792"/>
+            <a:ext cx="5376672" cy="594360"/>
           </a:xfrm>
           <a:prstGeom prst="roundRect">
             <a:avLst/>
@@ -4657,8 +4657,8 @@
         </p:nvSpPr>
         <p:spPr>
           <a:xfrm>
-            <a:off x="777240" y="1289304"/>
-            <a:ext cx="5010912" cy="548640"/>
+            <a:off x="758952" y="1280160"/>
+            <a:ext cx="5047488" cy="521208"/>
           </a:xfrm>
           <a:prstGeom prst="rect">
             <a:avLst/>
@@ -4672,19 +4672,19 @@
           <a:lstStyle/>
           <a:p>
             <a:pPr>
-              <a:defRPr sz="1550" b="1">
+              <a:defRPr sz="1450" b="1">
                 <a:solidFill>
                   <a:srgbClr val="FFFFFF"/>
                 </a:solidFill>
               </a:defRPr>
             </a:pPr>
             <a:r>
-              <a:t>Future Roadmap (Post-Hackathon)</a:t>
-            </a:r>
-          </a:p>
-          <a:p>
-            <a:pPr>
-              <a:defRPr sz="1000" b="1">
+              <a:t>Future Scope &amp; Deployment Roadmap</a:t>
+            </a:r>
+          </a:p>
+          <a:p>
+            <a:pPr>
+              <a:defRPr sz="950" b="1">
                 <a:solidFill>
                   <a:srgbClr val="E0F2FE"/>
                 </a:solidFill>
@@ -4704,8 +4704,8 @@
         </p:nvSpPr>
         <p:spPr>
           <a:xfrm>
-            <a:off x="777240" y="1965960"/>
-            <a:ext cx="5010912" cy="2304288"/>
+            <a:off x="758952" y="1901952"/>
+            <a:ext cx="5047488" cy="2386584"/>
           </a:xfrm>
           <a:prstGeom prst="rect">
             <a:avLst/>
@@ -4720,9 +4720,9 @@
           <a:p>
             <a:pPr>
               <a:spcAft>
-                <a:spcPts val="900"/>
-              </a:spcAft>
-              <a:defRPr sz="1300">
+                <a:spcPts val="800"/>
+              </a:spcAft>
+              <a:defRPr sz="1250">
                 <a:solidFill>
                   <a:srgbClr val="0F172A"/>
                 </a:solidFill>
@@ -4735,24 +4735,24 @@
           <a:p>
             <a:pPr>
               <a:spcAft>
-                <a:spcPts val="900"/>
-              </a:spcAft>
-              <a:defRPr sz="1300">
-                <a:solidFill>
-                  <a:srgbClr val="0F172A"/>
-                </a:solidFill>
-              </a:defRPr>
-            </a:pPr>
-            <a:r>
-              <a:t>•  Phase 2: Student Profile Subscription (Alerts delivered only for specific branch &amp; semester).</a:t>
-            </a:r>
-          </a:p>
-          <a:p>
-            <a:pPr>
-              <a:spcAft>
-                <a:spcPts val="900"/>
-              </a:spcAft>
-              <a:defRPr sz="1300">
+                <a:spcPts val="800"/>
+              </a:spcAft>
+              <a:defRPr sz="1250">
+                <a:solidFill>
+                  <a:srgbClr val="0F172A"/>
+                </a:solidFill>
+              </a:defRPr>
+            </a:pPr>
+            <a:r>
+              <a:t>•  Phase 2: Student Profile Subscription (Alerts tailored to specific branch &amp; sem).</a:t>
+            </a:r>
+          </a:p>
+          <a:p>
+            <a:pPr>
+              <a:spcAft>
+                <a:spcPts val="800"/>
+              </a:spcAft>
+              <a:defRPr sz="1250">
                 <a:solidFill>
                   <a:srgbClr val="0F172A"/>
                 </a:solidFill>
@@ -4765,16 +4765,16 @@
           <a:p>
             <a:pPr>
               <a:spcAft>
-                <a:spcPts val="900"/>
-              </a:spcAft>
-              <a:defRPr sz="1300">
-                <a:solidFill>
-                  <a:srgbClr val="0F172A"/>
-                </a:solidFill>
-              </a:defRPr>
-            </a:pPr>
-            <a:r>
-              <a:t>•  Phase 4: Scaling the framework to Gujarat University, HNGU, VNSGU &amp; other state universities.</a:t>
+                <a:spcPts val="800"/>
+              </a:spcAft>
+              <a:defRPr sz="1250">
+                <a:solidFill>
+                  <a:srgbClr val="0F172A"/>
+                </a:solidFill>
+              </a:defRPr>
+            </a:pPr>
+            <a:r>
+              <a:t>•  Phase 4: Scaling the framework to Gujarat University, HNGU &amp; other state universities.</a:t>
             </a:r>
           </a:p>
         </p:txBody>
@@ -4833,7 +4833,7 @@
         <p:spPr>
           <a:xfrm>
             <a:off x="6190488" y="1234440"/>
-            <a:ext cx="5376672" cy="621792"/>
+            <a:ext cx="5376672" cy="594360"/>
           </a:xfrm>
           <a:prstGeom prst="roundRect">
             <a:avLst/>
@@ -4875,8 +4875,8 @@
         </p:nvSpPr>
         <p:spPr>
           <a:xfrm>
-            <a:off x="6373368" y="1289304"/>
-            <a:ext cx="5010912" cy="548640"/>
+            <a:off x="6355080" y="1280160"/>
+            <a:ext cx="5047488" cy="521208"/>
           </a:xfrm>
           <a:prstGeom prst="rect">
             <a:avLst/>
@@ -4890,26 +4890,26 @@
           <a:lstStyle/>
           <a:p>
             <a:pPr>
-              <a:defRPr sz="1550" b="1">
+              <a:defRPr sz="1450" b="1">
                 <a:solidFill>
                   <a:srgbClr val="FFFFFF"/>
                 </a:solidFill>
               </a:defRPr>
             </a:pPr>
             <a:r>
-              <a:t>Summary &amp; Core Value</a:t>
-            </a:r>
-          </a:p>
-          <a:p>
-            <a:pPr>
-              <a:defRPr sz="1000" b="1">
+              <a:t>Executive Summary</a:t>
+            </a:r>
+          </a:p>
+          <a:p>
+            <a:pPr>
+              <a:defRPr sz="950" b="1">
                 <a:solidFill>
                   <a:srgbClr val="E0F2FE"/>
                 </a:solidFill>
               </a:defRPr>
             </a:pPr>
             <a:r>
-              <a:t>EXECUTIVE SUMMARY</a:t>
+              <a:t>CORE VALUE</a:t>
             </a:r>
           </a:p>
         </p:txBody>
@@ -4922,8 +4922,8 @@
         </p:nvSpPr>
         <p:spPr>
           <a:xfrm>
-            <a:off x="6373368" y="1965960"/>
-            <a:ext cx="5010912" cy="2304288"/>
+            <a:off x="6355080" y="1901952"/>
+            <a:ext cx="5047488" cy="2386584"/>
           </a:xfrm>
           <a:prstGeom prst="rect">
             <a:avLst/>
@@ -4938,9 +4938,9 @@
           <a:p>
             <a:pPr>
               <a:spcAft>
-                <a:spcPts val="900"/>
-              </a:spcAft>
-              <a:defRPr sz="1300">
+                <a:spcPts val="800"/>
+              </a:spcAft>
+              <a:defRPr sz="1250">
                 <a:solidFill>
                   <a:srgbClr val="0F172A"/>
                 </a:solidFill>
@@ -4953,9 +4953,9 @@
           <a:p>
             <a:pPr>
               <a:spcAft>
-                <a:spcPts val="900"/>
-              </a:spcAft>
-              <a:defRPr sz="1300">
+                <a:spcPts val="800"/>
+              </a:spcAft>
+              <a:defRPr sz="1250">
                 <a:solidFill>
                   <a:srgbClr val="0F172A"/>
                 </a:solidFill>
@@ -4968,9 +4968,9 @@
           <a:p>
             <a:pPr>
               <a:spcAft>
-                <a:spcPts val="900"/>
-              </a:spcAft>
-              <a:defRPr sz="1300">
+                <a:spcPts val="800"/>
+              </a:spcAft>
+              <a:defRPr sz="1250">
                 <a:solidFill>
                   <a:srgbClr val="0F172A"/>
                 </a:solidFill>
@@ -4983,9 +4983,9 @@
           <a:p>
             <a:pPr>
               <a:spcAft>
-                <a:spcPts val="900"/>
-              </a:spcAft>
-              <a:defRPr sz="1300">
+                <a:spcPts val="800"/>
+              </a:spcAft>
+              <a:defRPr sz="1250">
                 <a:solidFill>
                   <a:srgbClr val="0F172A"/>
                 </a:solidFill>
@@ -4998,9 +4998,9 @@
           <a:p>
             <a:pPr>
               <a:spcAft>
-                <a:spcPts val="900"/>
-              </a:spcAft>
-              <a:defRPr sz="1300">
+                <a:spcPts val="800"/>
+              </a:spcAft>
+              <a:defRPr sz="1250">
                 <a:solidFill>
                   <a:srgbClr val="0F172A"/>
                 </a:solidFill>
@@ -5057,26 +5057,26 @@
               <a:spcAft>
                 <a:spcPts val="800"/>
               </a:spcAft>
-              <a:defRPr sz="2300" b="1">
+              <a:defRPr sz="2200" b="1">
                 <a:solidFill>
                   <a:srgbClr val="F97316"/>
                 </a:solidFill>
               </a:defRPr>
             </a:pPr>
             <a:r>
-              <a:t>Thank You! We are Ready for Jury Defense &amp; Live Demonstration.</a:t>
+              <a:t>Thank You! We are Ready for Project Evaluation &amp; Live Demonstration.</a:t>
             </a:r>
           </a:p>
           <a:p>
             <a:pPr algn="ctr">
-              <a:defRPr sz="1350">
+              <a:defRPr sz="1300">
                 <a:solidFill>
                   <a:srgbClr val="FFFFFF"/>
                 </a:solidFill>
               </a:defRPr>
             </a:pPr>
             <a:r>
-              <a:t>Smart India Hackathon 2024  •  Team: GTU Innovators  •  Open-Source &amp; Deployable Today</a:t>
+              <a:t>GTU Automated Alert System  •  Team: GTU Innovators  •  Open-Source &amp; Deployable Today</a:t>
             </a:r>
           </a:p>
         </p:txBody>
@@ -5236,8 +5236,8 @@
         </p:nvSpPr>
         <p:spPr>
           <a:xfrm>
-            <a:off x="7498079" y="164592"/>
-            <a:ext cx="4114800" cy="777240"/>
+            <a:off x="7132320" y="164592"/>
+            <a:ext cx="4480560" cy="777240"/>
           </a:xfrm>
           <a:prstGeom prst="rect">
             <a:avLst/>
@@ -5251,18 +5251,18 @@
           <a:lstStyle/>
           <a:p>
             <a:pPr algn="r">
-              <a:defRPr sz="1100" b="1">
+              <a:defRPr sz="1050" b="1">
                 <a:solidFill>
                   <a:srgbClr val="F97316"/>
                 </a:solidFill>
               </a:defRPr>
             </a:pPr>
             <a:r>
-              <a:t>SMART INDIA HACKATHON 2024</a:t>
+              <a:t>GUJARAT TECHNOLOGICAL UNIVERSITY</a:t>
             </a:r>
             <a:br/>
             <a:r>
-              <a:t>THEME: SMART EDUCATION / AUTOMATION</a:t>
+              <a:t>CAMPUS AUTOMATION &amp; STUDENT WELFARE</a:t>
             </a:r>
           </a:p>
         </p:txBody>
@@ -5276,7 +5276,7 @@
         <p:spPr>
           <a:xfrm>
             <a:off x="594360" y="201168"/>
-            <a:ext cx="6858000" cy="685800"/>
+            <a:ext cx="6583680" cy="685800"/>
           </a:xfrm>
           <a:prstGeom prst="rect">
             <a:avLst/>
@@ -5356,7 +5356,7 @@
         <p:spPr>
           <a:xfrm>
             <a:off x="594360" y="6510528"/>
-            <a:ext cx="7772400" cy="320040"/>
+            <a:ext cx="8046720" cy="320040"/>
           </a:xfrm>
           <a:prstGeom prst="rect">
             <a:avLst/>
@@ -5377,7 +5377,7 @@
               </a:defRPr>
             </a:pPr>
             <a:r>
-              <a:t>SIH 2024  |  Problem: GTU Notice Broadcast Automation  |  Team: GTU Innovators</a:t>
+              <a:t>GTU Circular &amp; Notification Alert System  |  Department of Computer / IT Engineering</a:t>
             </a:r>
           </a:p>
         </p:txBody>
@@ -5471,7 +5471,7 @@
         <p:spPr>
           <a:xfrm>
             <a:off x="594360" y="1234440"/>
-            <a:ext cx="3511296" cy="621792"/>
+            <a:ext cx="3511296" cy="594360"/>
           </a:xfrm>
           <a:prstGeom prst="roundRect">
             <a:avLst/>
@@ -5513,8 +5513,8 @@
         </p:nvSpPr>
         <p:spPr>
           <a:xfrm>
-            <a:off x="777240" y="1289304"/>
-            <a:ext cx="3145536" cy="548640"/>
+            <a:off x="758952" y="1280160"/>
+            <a:ext cx="3182112" cy="521208"/>
           </a:xfrm>
           <a:prstGeom prst="rect">
             <a:avLst/>
@@ -5528,7 +5528,7 @@
           <a:lstStyle/>
           <a:p>
             <a:pPr>
-              <a:defRPr sz="1550" b="1">
+              <a:defRPr sz="1450" b="1">
                 <a:solidFill>
                   <a:srgbClr val="FFFFFF"/>
                 </a:solidFill>
@@ -5540,7 +5540,7 @@
           </a:p>
           <a:p>
             <a:pPr>
-              <a:defRPr sz="1000" b="1">
+              <a:defRPr sz="950" b="1">
                 <a:solidFill>
                   <a:srgbClr val="E0F2FE"/>
                 </a:solidFill>
@@ -5560,8 +5560,8 @@
         </p:nvSpPr>
         <p:spPr>
           <a:xfrm>
-            <a:off x="777240" y="1965960"/>
-            <a:ext cx="3145536" cy="4315968"/>
+            <a:off x="758952" y="1901952"/>
+            <a:ext cx="3182112" cy="4398264"/>
           </a:xfrm>
           <a:prstGeom prst="rect">
             <a:avLst/>
@@ -5576,9 +5576,9 @@
           <a:p>
             <a:pPr>
               <a:spcAft>
-                <a:spcPts val="1100"/>
-              </a:spcAft>
-              <a:defRPr sz="1300">
+                <a:spcPts val="1000"/>
+              </a:spcAft>
+              <a:defRPr sz="1250">
                 <a:solidFill>
                   <a:srgbClr val="0F172A"/>
                 </a:solidFill>
@@ -5591,9 +5591,9 @@
           <a:p>
             <a:pPr>
               <a:spcAft>
-                <a:spcPts val="1100"/>
-              </a:spcAft>
-              <a:defRPr sz="1300">
+                <a:spcPts val="1000"/>
+              </a:spcAft>
+              <a:defRPr sz="1250">
                 <a:solidFill>
                   <a:srgbClr val="0F172A"/>
                 </a:solidFill>
@@ -5606,24 +5606,24 @@
           <a:p>
             <a:pPr>
               <a:spcAft>
-                <a:spcPts val="1100"/>
-              </a:spcAft>
-              <a:defRPr sz="1300">
-                <a:solidFill>
-                  <a:srgbClr val="0F172A"/>
-                </a:solidFill>
-              </a:defRPr>
-            </a:pPr>
-            <a:r>
-              <a:t>•  In extreme cases, missed dates lead to detention or skipped semesters.</a:t>
-            </a:r>
-          </a:p>
-          <a:p>
-            <a:pPr>
-              <a:spcAft>
-                <a:spcPts val="1100"/>
-              </a:spcAft>
-              <a:defRPr sz="1300">
+                <a:spcPts val="1000"/>
+              </a:spcAft>
+              <a:defRPr sz="1250">
+                <a:solidFill>
+                  <a:srgbClr val="0F172A"/>
+                </a:solidFill>
+              </a:defRPr>
+            </a:pPr>
+            <a:r>
+              <a:t>•  In extreme cases, missed dates lead to detention or skipped terms.</a:t>
+            </a:r>
+          </a:p>
+          <a:p>
+            <a:pPr>
+              <a:spcAft>
+                <a:spcPts val="1000"/>
+              </a:spcAft>
+              <a:defRPr sz="1250">
                 <a:solidFill>
                   <a:srgbClr val="0F172A"/>
                 </a:solidFill>
@@ -5636,9 +5636,9 @@
           <a:p>
             <a:pPr>
               <a:spcAft>
-                <a:spcPts val="1100"/>
-              </a:spcAft>
-              <a:defRPr sz="1300">
+                <a:spcPts val="1000"/>
+              </a:spcAft>
+              <a:defRPr sz="1250">
                 <a:solidFill>
                   <a:srgbClr val="0F172A"/>
                 </a:solidFill>
@@ -5651,16 +5651,16 @@
           <a:p>
             <a:pPr>
               <a:spcAft>
-                <a:spcPts val="1100"/>
-              </a:spcAft>
-              <a:defRPr sz="1300">
-                <a:solidFill>
-                  <a:srgbClr val="0F172A"/>
-                </a:solidFill>
-              </a:defRPr>
-            </a:pPr>
-            <a:r>
-              <a:t>•  Students from remote areas lack immediate campus access.</a:t>
+                <a:spcPts val="1000"/>
+              </a:spcAft>
+              <a:defRPr sz="1250">
+                <a:solidFill>
+                  <a:srgbClr val="0F172A"/>
+                </a:solidFill>
+              </a:defRPr>
+            </a:pPr>
+            <a:r>
+              <a:t>•  Students from remote areas lack immediate campus notice access.</a:t>
             </a:r>
           </a:p>
         </p:txBody>
@@ -5719,7 +5719,7 @@
         <p:spPr>
           <a:xfrm>
             <a:off x="4325112" y="1234440"/>
-            <a:ext cx="3511296" cy="621792"/>
+            <a:ext cx="3511296" cy="594360"/>
           </a:xfrm>
           <a:prstGeom prst="roundRect">
             <a:avLst/>
@@ -5761,8 +5761,8 @@
         </p:nvSpPr>
         <p:spPr>
           <a:xfrm>
-            <a:off x="4507992" y="1289304"/>
-            <a:ext cx="3145536" cy="548640"/>
+            <a:off x="4489704" y="1280160"/>
+            <a:ext cx="3182112" cy="521208"/>
           </a:xfrm>
           <a:prstGeom prst="rect">
             <a:avLst/>
@@ -5776,7 +5776,7 @@
           <a:lstStyle/>
           <a:p>
             <a:pPr>
-              <a:defRPr sz="1550" b="1">
+              <a:defRPr sz="1450" b="1">
                 <a:solidFill>
                   <a:srgbClr val="FFFFFF"/>
                 </a:solidFill>
@@ -5788,7 +5788,7 @@
           </a:p>
           <a:p>
             <a:pPr>
-              <a:defRPr sz="1000" b="1">
+              <a:defRPr sz="950" b="1">
                 <a:solidFill>
                   <a:srgbClr val="E0F2FE"/>
                 </a:solidFill>
@@ -5808,8 +5808,8 @@
         </p:nvSpPr>
         <p:spPr>
           <a:xfrm>
-            <a:off x="4507992" y="1965960"/>
-            <a:ext cx="3145536" cy="4315968"/>
+            <a:off x="4489704" y="1901952"/>
+            <a:ext cx="3182112" cy="4398264"/>
           </a:xfrm>
           <a:prstGeom prst="rect">
             <a:avLst/>
@@ -5824,39 +5824,39 @@
           <a:p>
             <a:pPr>
               <a:spcAft>
-                <a:spcPts val="1100"/>
-              </a:spcAft>
-              <a:defRPr sz="1300">
-                <a:solidFill>
-                  <a:srgbClr val="0F172A"/>
-                </a:solidFill>
-              </a:defRPr>
-            </a:pPr>
-            <a:r>
-              <a:t>•  Class Coordinators &amp; CRs must manually check GTU portal multiple times daily.</a:t>
-            </a:r>
-          </a:p>
-          <a:p>
-            <a:pPr>
-              <a:spcAft>
-                <a:spcPts val="1100"/>
-              </a:spcAft>
-              <a:defRPr sz="1300">
-                <a:solidFill>
-                  <a:srgbClr val="0F172A"/>
-                </a:solidFill>
-              </a:defRPr>
-            </a:pPr>
-            <a:r>
-              <a:t>•  Manual downloading, renaming, and sharing in unorganized WhatsApp groups.</a:t>
-            </a:r>
-          </a:p>
-          <a:p>
-            <a:pPr>
-              <a:spcAft>
-                <a:spcPts val="1100"/>
-              </a:spcAft>
-              <a:defRPr sz="1300">
+                <a:spcPts val="1000"/>
+              </a:spcAft>
+              <a:defRPr sz="1250">
+                <a:solidFill>
+                  <a:srgbClr val="0F172A"/>
+                </a:solidFill>
+              </a:defRPr>
+            </a:pPr>
+            <a:r>
+              <a:t>•  Class Coordinators &amp; CRs must manually check GTU portal daily.</a:t>
+            </a:r>
+          </a:p>
+          <a:p>
+            <a:pPr>
+              <a:spcAft>
+                <a:spcPts val="1000"/>
+              </a:spcAft>
+              <a:defRPr sz="1250">
+                <a:solidFill>
+                  <a:srgbClr val="0F172A"/>
+                </a:solidFill>
+              </a:defRPr>
+            </a:pPr>
+            <a:r>
+              <a:t>•  Manual downloading, renaming, and sharing in noisy WhatsApp groups.</a:t>
+            </a:r>
+          </a:p>
+          <a:p>
+            <a:pPr>
+              <a:spcAft>
+                <a:spcPts val="1000"/>
+              </a:spcAft>
+              <a:defRPr sz="1250">
                 <a:solidFill>
                   <a:srgbClr val="0F172A"/>
                 </a:solidFill>
@@ -5869,9 +5869,9 @@
           <a:p>
             <a:pPr>
               <a:spcAft>
-                <a:spcPts val="1100"/>
-              </a:spcAft>
-              <a:defRPr sz="1300">
+                <a:spcPts val="1000"/>
+              </a:spcAft>
+              <a:defRPr sz="1250">
                 <a:solidFill>
                   <a:srgbClr val="0F172A"/>
                 </a:solidFill>
@@ -5884,9 +5884,9 @@
           <a:p>
             <a:pPr>
               <a:spcAft>
-                <a:spcPts val="1100"/>
-              </a:spcAft>
-              <a:defRPr sz="1300">
+                <a:spcPts val="1000"/>
+              </a:spcAft>
+              <a:defRPr sz="1250">
                 <a:solidFill>
                   <a:srgbClr val="0F172A"/>
                 </a:solidFill>
@@ -5899,9 +5899,9 @@
           <a:p>
             <a:pPr>
               <a:spcAft>
-                <a:spcPts val="1100"/>
-              </a:spcAft>
-              <a:defRPr sz="1300">
+                <a:spcPts val="1000"/>
+              </a:spcAft>
+              <a:defRPr sz="1250">
                 <a:solidFill>
                   <a:srgbClr val="0F172A"/>
                 </a:solidFill>
@@ -5967,7 +5967,7 @@
         <p:spPr>
           <a:xfrm>
             <a:off x="8055864" y="1234440"/>
-            <a:ext cx="3511296" cy="621792"/>
+            <a:ext cx="3511296" cy="594360"/>
           </a:xfrm>
           <a:prstGeom prst="roundRect">
             <a:avLst/>
@@ -6009,8 +6009,8 @@
         </p:nvSpPr>
         <p:spPr>
           <a:xfrm>
-            <a:off x="8238744" y="1289304"/>
-            <a:ext cx="3145536" cy="548640"/>
+            <a:off x="8220456" y="1280160"/>
+            <a:ext cx="3182112" cy="521208"/>
           </a:xfrm>
           <a:prstGeom prst="rect">
             <a:avLst/>
@@ -6024,7 +6024,7 @@
           <a:lstStyle/>
           <a:p>
             <a:pPr>
-              <a:defRPr sz="1550" b="1">
+              <a:defRPr sz="1450" b="1">
                 <a:solidFill>
                   <a:srgbClr val="FFFFFF"/>
                 </a:solidFill>
@@ -6036,7 +6036,7 @@
           </a:p>
           <a:p>
             <a:pPr>
-              <a:defRPr sz="1000" b="1">
+              <a:defRPr sz="950" b="1">
                 <a:solidFill>
                   <a:srgbClr val="E0F2FE"/>
                 </a:solidFill>
@@ -6056,8 +6056,8 @@
         </p:nvSpPr>
         <p:spPr>
           <a:xfrm>
-            <a:off x="8238744" y="1965960"/>
-            <a:ext cx="3145536" cy="4315968"/>
+            <a:off x="8220456" y="1901952"/>
+            <a:ext cx="3182112" cy="4398264"/>
           </a:xfrm>
           <a:prstGeom prst="rect">
             <a:avLst/>
@@ -6072,24 +6072,24 @@
           <a:p>
             <a:pPr>
               <a:spcAft>
-                <a:spcPts val="1100"/>
-              </a:spcAft>
-              <a:defRPr sz="1300">
-                <a:solidFill>
-                  <a:srgbClr val="0F172A"/>
-                </a:solidFill>
-              </a:defRPr>
-            </a:pPr>
-            <a:r>
-              <a:t>•  GTU publishes 10 to 20 notices daily across all engineering and pharmacy branches.</a:t>
-            </a:r>
-          </a:p>
-          <a:p>
-            <a:pPr>
-              <a:spcAft>
-                <a:spcPts val="1100"/>
-              </a:spcAft>
-              <a:defRPr sz="1300">
+                <a:spcPts val="1000"/>
+              </a:spcAft>
+              <a:defRPr sz="1250">
+                <a:solidFill>
+                  <a:srgbClr val="0F172A"/>
+                </a:solidFill>
+              </a:defRPr>
+            </a:pPr>
+            <a:r>
+              <a:t>•  GTU publishes 10 to 20 notices daily across multiple faculties.</a:t>
+            </a:r>
+          </a:p>
+          <a:p>
+            <a:pPr>
+              <a:spcAft>
+                <a:spcPts val="1000"/>
+              </a:spcAft>
+              <a:defRPr sz="1250">
                 <a:solidFill>
                   <a:srgbClr val="0F172A"/>
                 </a:solidFill>
@@ -6102,24 +6102,24 @@
           <a:p>
             <a:pPr>
               <a:spcAft>
-                <a:spcPts val="1100"/>
-              </a:spcAft>
-              <a:defRPr sz="1300">
-                <a:solidFill>
-                  <a:srgbClr val="0F172A"/>
-                </a:solidFill>
-              </a:defRPr>
-            </a:pPr>
-            <a:r>
-              <a:t>•  GTU website suffers high latency and crashes during major exam/result periods.</a:t>
-            </a:r>
-          </a:p>
-          <a:p>
-            <a:pPr>
-              <a:spcAft>
-                <a:spcPts val="1100"/>
-              </a:spcAft>
-              <a:defRPr sz="1300">
+                <a:spcPts val="1000"/>
+              </a:spcAft>
+              <a:defRPr sz="1250">
+                <a:solidFill>
+                  <a:srgbClr val="0F172A"/>
+                </a:solidFill>
+              </a:defRPr>
+            </a:pPr>
+            <a:r>
+              <a:t>•  GTU website suffers high latency and crashes during major exam periods.</a:t>
+            </a:r>
+          </a:p>
+          <a:p>
+            <a:pPr>
+              <a:spcAft>
+                <a:spcPts val="1000"/>
+              </a:spcAft>
+              <a:defRPr sz="1250">
                 <a:solidFill>
                   <a:srgbClr val="0F172A"/>
                 </a:solidFill>
@@ -6132,24 +6132,24 @@
           <a:p>
             <a:pPr>
               <a:spcAft>
-                <a:spcPts val="1100"/>
-              </a:spcAft>
-              <a:defRPr sz="1300">
-                <a:solidFill>
-                  <a:srgbClr val="0F172A"/>
-                </a:solidFill>
-              </a:defRPr>
-            </a:pPr>
-            <a:r>
-              <a:t>•  Rural &amp; regional students face difficulty navigating complex portal links.</a:t>
-            </a:r>
-          </a:p>
-          <a:p>
-            <a:pPr>
-              <a:spcAft>
-                <a:spcPts val="1100"/>
-              </a:spcAft>
-              <a:defRPr sz="1300">
+                <a:spcPts val="1000"/>
+              </a:spcAft>
+              <a:defRPr sz="1250">
+                <a:solidFill>
+                  <a:srgbClr val="0F172A"/>
+                </a:solidFill>
+              </a:defRPr>
+            </a:pPr>
+            <a:r>
+              <a:t>•  Rural &amp; regional students face difficulty navigating portal links.</a:t>
+            </a:r>
+          </a:p>
+          <a:p>
+            <a:pPr>
+              <a:spcAft>
+                <a:spcPts val="1000"/>
+              </a:spcAft>
+              <a:defRPr sz="1250">
                 <a:solidFill>
                   <a:srgbClr val="0F172A"/>
                 </a:solidFill>
@@ -6316,8 +6316,8 @@
         </p:nvSpPr>
         <p:spPr>
           <a:xfrm>
-            <a:off x="7498079" y="164592"/>
-            <a:ext cx="4114800" cy="777240"/>
+            <a:off x="7132320" y="164592"/>
+            <a:ext cx="4480560" cy="777240"/>
           </a:xfrm>
           <a:prstGeom prst="rect">
             <a:avLst/>
@@ -6331,18 +6331,18 @@
           <a:lstStyle/>
           <a:p>
             <a:pPr algn="r">
-              <a:defRPr sz="1100" b="1">
+              <a:defRPr sz="1050" b="1">
                 <a:solidFill>
                   <a:srgbClr val="F97316"/>
                 </a:solidFill>
               </a:defRPr>
             </a:pPr>
             <a:r>
-              <a:t>SMART INDIA HACKATHON 2024</a:t>
+              <a:t>GUJARAT TECHNOLOGICAL UNIVERSITY</a:t>
             </a:r>
             <a:br/>
             <a:r>
-              <a:t>THEME: SMART EDUCATION / AUTOMATION</a:t>
+              <a:t>CAMPUS AUTOMATION &amp; STUDENT WELFARE</a:t>
             </a:r>
           </a:p>
         </p:txBody>
@@ -6356,7 +6356,7 @@
         <p:spPr>
           <a:xfrm>
             <a:off x="594360" y="201168"/>
-            <a:ext cx="6858000" cy="685800"/>
+            <a:ext cx="6583680" cy="685800"/>
           </a:xfrm>
           <a:prstGeom prst="rect">
             <a:avLst/>
@@ -6377,7 +6377,7 @@
               </a:defRPr>
             </a:pPr>
             <a:r>
-              <a:t>Proposed Solution: An Autonomous University Broadcast Ecosystem</a:t>
+              <a:t>Proposed Solution: Autonomous Notice Broadcast Ecosystem</a:t>
             </a:r>
           </a:p>
         </p:txBody>
@@ -6436,7 +6436,7 @@
         <p:spPr>
           <a:xfrm>
             <a:off x="594360" y="6510528"/>
-            <a:ext cx="7772400" cy="320040"/>
+            <a:ext cx="8046720" cy="320040"/>
           </a:xfrm>
           <a:prstGeom prst="rect">
             <a:avLst/>
@@ -6457,7 +6457,7 @@
               </a:defRPr>
             </a:pPr>
             <a:r>
-              <a:t>SIH 2024  |  Problem: GTU Notice Broadcast Automation  |  Team: GTU Innovators</a:t>
+              <a:t>GTU Circular &amp; Notification Alert System  |  Department of Computer / IT Engineering</a:t>
             </a:r>
           </a:p>
         </p:txBody>
@@ -6505,8 +6505,8 @@
         </p:nvSpPr>
         <p:spPr>
           <a:xfrm>
-            <a:off x="594360" y="1234440"/>
-            <a:ext cx="5376672" cy="2514600"/>
+            <a:off x="594360" y="1207008"/>
+            <a:ext cx="5376672" cy="2542032"/>
           </a:xfrm>
           <a:prstGeom prst="roundRect">
             <a:avLst/>
@@ -6550,8 +6550,8 @@
         </p:nvSpPr>
         <p:spPr>
           <a:xfrm>
-            <a:off x="594360" y="1234440"/>
-            <a:ext cx="5376672" cy="530352"/>
+            <a:off x="594360" y="1207008"/>
+            <a:ext cx="5376672" cy="475488"/>
           </a:xfrm>
           <a:prstGeom prst="roundRect">
             <a:avLst/>
@@ -6593,8 +6593,8 @@
         </p:nvSpPr>
         <p:spPr>
           <a:xfrm>
-            <a:off x="777240" y="1289304"/>
-            <a:ext cx="5010912" cy="457200"/>
+            <a:off x="758952" y="1252728"/>
+            <a:ext cx="5047488" cy="402336"/>
           </a:xfrm>
           <a:prstGeom prst="rect">
             <a:avLst/>
@@ -6608,7 +6608,7 @@
           <a:lstStyle/>
           <a:p>
             <a:pPr>
-              <a:defRPr sz="1550" b="1">
+              <a:defRPr sz="1450" b="1">
                 <a:solidFill>
                   <a:srgbClr val="FFFFFF"/>
                 </a:solidFill>
@@ -6628,8 +6628,8 @@
         </p:nvSpPr>
         <p:spPr>
           <a:xfrm>
-            <a:off x="777240" y="1874520"/>
-            <a:ext cx="5010912" cy="1801368"/>
+            <a:off x="758952" y="1755648"/>
+            <a:ext cx="5047488" cy="1938528"/>
           </a:xfrm>
           <a:prstGeom prst="rect">
             <a:avLst/>
@@ -6644,54 +6644,54 @@
           <a:p>
             <a:pPr>
               <a:spcAft>
-                <a:spcPts val="1000"/>
-              </a:spcAft>
-              <a:defRPr sz="1350">
-                <a:solidFill>
-                  <a:srgbClr val="0F172A"/>
-                </a:solidFill>
-              </a:defRPr>
-            </a:pPr>
-            <a:r>
-              <a:t>•  Background polling engine monitors official GTU portal 24/7 every 15 minutes.</a:t>
-            </a:r>
-          </a:p>
-          <a:p>
-            <a:pPr>
-              <a:spcAft>
-                <a:spcPts val="1000"/>
-              </a:spcAft>
-              <a:defRPr sz="1350">
-                <a:solidFill>
-                  <a:srgbClr val="0F172A"/>
-                </a:solidFill>
-              </a:defRPr>
-            </a:pPr>
-            <a:r>
-              <a:t>•  Dispatches alerts to Telegram channels, Discord servers, and student bots within 5 seconds.</a:t>
-            </a:r>
-          </a:p>
-          <a:p>
-            <a:pPr>
-              <a:spcAft>
-                <a:spcPts val="1000"/>
-              </a:spcAft>
-              <a:defRPr sz="1350">
-                <a:solidFill>
-                  <a:srgbClr val="0F172A"/>
-                </a:solidFill>
-              </a:defRPr>
-            </a:pPr>
-            <a:r>
-              <a:t>•  Includes direct 1-click official PDF link (no need to open the university website).</a:t>
-            </a:r>
-          </a:p>
-          <a:p>
-            <a:pPr>
-              <a:spcAft>
-                <a:spcPts val="1000"/>
-              </a:spcAft>
-              <a:defRPr sz="1350">
+                <a:spcPts val="600"/>
+              </a:spcAft>
+              <a:defRPr sz="1200">
+                <a:solidFill>
+                  <a:srgbClr val="0F172A"/>
+                </a:solidFill>
+              </a:defRPr>
+            </a:pPr>
+            <a:r>
+              <a:t>•  24/7 automated background polling of official GTU portal.</a:t>
+            </a:r>
+          </a:p>
+          <a:p>
+            <a:pPr>
+              <a:spcAft>
+                <a:spcPts val="600"/>
+              </a:spcAft>
+              <a:defRPr sz="1200">
+                <a:solidFill>
+                  <a:srgbClr val="0F172A"/>
+                </a:solidFill>
+              </a:defRPr>
+            </a:pPr>
+            <a:r>
+              <a:t>•  Instant alerts delivered to Telegram &amp; Discord within 5 seconds.</a:t>
+            </a:r>
+          </a:p>
+          <a:p>
+            <a:pPr>
+              <a:spcAft>
+                <a:spcPts val="600"/>
+              </a:spcAft>
+              <a:defRPr sz="1200">
+                <a:solidFill>
+                  <a:srgbClr val="0F172A"/>
+                </a:solidFill>
+              </a:defRPr>
+            </a:pPr>
+            <a:r>
+              <a:t>•  Direct 1-click official PDF link (no need to open university website).</a:t>
+            </a:r>
+          </a:p>
+          <a:p>
+            <a:pPr>
+              <a:spcAft>
+                <a:spcPts val="600"/>
+              </a:spcAft>
+              <a:defRPr sz="1200">
                 <a:solidFill>
                   <a:srgbClr val="0F172A"/>
                 </a:solidFill>
@@ -6711,8 +6711,8 @@
         </p:nvSpPr>
         <p:spPr>
           <a:xfrm>
-            <a:off x="6190488" y="1234440"/>
-            <a:ext cx="5376672" cy="2514600"/>
+            <a:off x="6190488" y="1207008"/>
+            <a:ext cx="5376672" cy="2542032"/>
           </a:xfrm>
           <a:prstGeom prst="roundRect">
             <a:avLst/>
@@ -6756,8 +6756,8 @@
         </p:nvSpPr>
         <p:spPr>
           <a:xfrm>
-            <a:off x="6190488" y="1234440"/>
-            <a:ext cx="5376672" cy="530352"/>
+            <a:off x="6190488" y="1207008"/>
+            <a:ext cx="5376672" cy="475488"/>
           </a:xfrm>
           <a:prstGeom prst="roundRect">
             <a:avLst/>
@@ -6799,8 +6799,8 @@
         </p:nvSpPr>
         <p:spPr>
           <a:xfrm>
-            <a:off x="6373368" y="1289304"/>
-            <a:ext cx="5010912" cy="457200"/>
+            <a:off x="6355080" y="1252728"/>
+            <a:ext cx="5047488" cy="402336"/>
           </a:xfrm>
           <a:prstGeom prst="rect">
             <a:avLst/>
@@ -6814,7 +6814,7 @@
           <a:lstStyle/>
           <a:p>
             <a:pPr>
-              <a:defRPr sz="1550" b="1">
+              <a:defRPr sz="1450" b="1">
                 <a:solidFill>
                   <a:srgbClr val="FFFFFF"/>
                 </a:solidFill>
@@ -6834,8 +6834,8 @@
         </p:nvSpPr>
         <p:spPr>
           <a:xfrm>
-            <a:off x="6373368" y="1874520"/>
-            <a:ext cx="5010912" cy="1801368"/>
+            <a:off x="6355080" y="1755648"/>
+            <a:ext cx="5047488" cy="1938528"/>
           </a:xfrm>
           <a:prstGeom prst="rect">
             <a:avLst/>
@@ -6850,24 +6850,24 @@
           <a:p>
             <a:pPr>
               <a:spcAft>
-                <a:spcPts val="1000"/>
-              </a:spcAft>
-              <a:defRPr sz="1350">
-                <a:solidFill>
-                  <a:srgbClr val="0F172A"/>
-                </a:solidFill>
-              </a:defRPr>
-            </a:pPr>
-            <a:r>
-              <a:t>•  Regex NLP accurately extracts degree (BE, ME, Diploma, Pharmacy, MBA, MCA).</a:t>
-            </a:r>
-          </a:p>
-          <a:p>
-            <a:pPr>
-              <a:spcAft>
-                <a:spcPts val="1000"/>
-              </a:spcAft>
-              <a:defRPr sz="1350">
+                <a:spcPts val="600"/>
+              </a:spcAft>
+              <a:defRPr sz="1200">
+                <a:solidFill>
+                  <a:srgbClr val="0F172A"/>
+                </a:solidFill>
+              </a:defRPr>
+            </a:pPr>
+            <a:r>
+              <a:t>•  Regex NLP accurately extracts degree (BE, ME, Diploma, MBA, MCA).</a:t>
+            </a:r>
+          </a:p>
+          <a:p>
+            <a:pPr>
+              <a:spcAft>
+                <a:spcPts val="600"/>
+              </a:spcAft>
+              <a:defRPr sz="1200">
                 <a:solidFill>
                   <a:srgbClr val="0F172A"/>
                 </a:solidFill>
@@ -6880,31 +6880,31 @@
           <a:p>
             <a:pPr>
               <a:spcAft>
-                <a:spcPts val="1000"/>
-              </a:spcAft>
-              <a:defRPr sz="1350">
-                <a:solidFill>
-                  <a:srgbClr val="0F172A"/>
-                </a:solidFill>
-              </a:defRPr>
-            </a:pPr>
-            <a:r>
-              <a:t>•  Automated Deadline &amp; Penalty Extractor highlights last dates and late fee slabs.</a:t>
-            </a:r>
-          </a:p>
-          <a:p>
-            <a:pPr>
-              <a:spcAft>
-                <a:spcPts val="1000"/>
-              </a:spcAft>
-              <a:defRPr sz="1350">
-                <a:solidFill>
-                  <a:srgbClr val="0F172A"/>
-                </a:solidFill>
-              </a:defRPr>
-            </a:pPr>
-            <a:r>
-              <a:t>•  Generates direct .ics calendar invite for instant Google / Apple Calendar sync.</a:t>
+                <a:spcPts val="600"/>
+              </a:spcAft>
+              <a:defRPr sz="1200">
+                <a:solidFill>
+                  <a:srgbClr val="0F172A"/>
+                </a:solidFill>
+              </a:defRPr>
+            </a:pPr>
+            <a:r>
+              <a:t>•  Extracts critical last dates and penalty fee slabs automatically.</a:t>
+            </a:r>
+          </a:p>
+          <a:p>
+            <a:pPr>
+              <a:spcAft>
+                <a:spcPts val="600"/>
+              </a:spcAft>
+              <a:defRPr sz="1200">
+                <a:solidFill>
+                  <a:srgbClr val="0F172A"/>
+                </a:solidFill>
+              </a:defRPr>
+            </a:pPr>
+            <a:r>
+              <a:t>•  Generates .ics calendar invite for Google &amp; Apple Calendar sync.</a:t>
             </a:r>
           </a:p>
         </p:txBody>
@@ -6918,7 +6918,7 @@
         <p:spPr>
           <a:xfrm>
             <a:off x="594360" y="3822191"/>
-            <a:ext cx="5376672" cy="2514600"/>
+            <a:ext cx="5376672" cy="2542032"/>
           </a:xfrm>
           <a:prstGeom prst="roundRect">
             <a:avLst/>
@@ -6963,7 +6963,7 @@
         <p:spPr>
           <a:xfrm>
             <a:off x="594360" y="3822191"/>
-            <a:ext cx="5376672" cy="530352"/>
+            <a:ext cx="5376672" cy="475488"/>
           </a:xfrm>
           <a:prstGeom prst="roundRect">
             <a:avLst/>
@@ -7005,8 +7005,8 @@
         </p:nvSpPr>
         <p:spPr>
           <a:xfrm>
-            <a:off x="777240" y="3877055"/>
-            <a:ext cx="5010912" cy="457200"/>
+            <a:off x="758952" y="3867911"/>
+            <a:ext cx="5047488" cy="402336"/>
           </a:xfrm>
           <a:prstGeom prst="rect">
             <a:avLst/>
@@ -7020,7 +7020,7 @@
           <a:lstStyle/>
           <a:p>
             <a:pPr>
-              <a:defRPr sz="1550" b="1">
+              <a:defRPr sz="1450" b="1">
                 <a:solidFill>
                   <a:srgbClr val="FFFFFF"/>
                 </a:solidFill>
@@ -7040,8 +7040,8 @@
         </p:nvSpPr>
         <p:spPr>
           <a:xfrm>
-            <a:off x="777240" y="4462271"/>
-            <a:ext cx="5010912" cy="1801368"/>
+            <a:off x="758952" y="4370831"/>
+            <a:ext cx="5047488" cy="1938528"/>
           </a:xfrm>
           <a:prstGeom prst="rect">
             <a:avLst/>
@@ -7056,61 +7056,61 @@
           <a:p>
             <a:pPr>
               <a:spcAft>
-                <a:spcPts val="1000"/>
-              </a:spcAft>
-              <a:defRPr sz="1350">
-                <a:solidFill>
-                  <a:srgbClr val="0F172A"/>
-                </a:solidFill>
-              </a:defRPr>
-            </a:pPr>
-            <a:r>
-              <a:t>•  Google Gemini AI summarizes complex 10-page circulars into 2 clear sentences.</a:t>
-            </a:r>
-          </a:p>
-          <a:p>
-            <a:pPr>
-              <a:spcAft>
-                <a:spcPts val="1000"/>
-              </a:spcAft>
-              <a:defRPr sz="1350">
-                <a:solidFill>
-                  <a:srgbClr val="0F172A"/>
-                </a:solidFill>
-              </a:defRPr>
-            </a:pPr>
-            <a:r>
-              <a:t>•  Smart offline heuristic fallback ensures zero downtime even without API keys.</a:t>
-            </a:r>
-          </a:p>
-          <a:p>
-            <a:pPr>
-              <a:spcAft>
-                <a:spcPts val="1000"/>
-              </a:spcAft>
-              <a:defRPr sz="1350">
-                <a:solidFill>
-                  <a:srgbClr val="0F172A"/>
-                </a:solidFill>
-              </a:defRPr>
-            </a:pPr>
-            <a:r>
-              <a:t>•  Bilingual templates (English + Gujarati) empower regional students and parents.</a:t>
-            </a:r>
-          </a:p>
-          <a:p>
-            <a:pPr>
-              <a:spcAft>
-                <a:spcPts val="1000"/>
-              </a:spcAft>
-              <a:defRPr sz="1350">
-                <a:solidFill>
-                  <a:srgbClr val="0F172A"/>
-                </a:solidFill>
-              </a:defRPr>
-            </a:pPr>
-            <a:r>
-              <a:t>•  Eliminates confusion regarding who needs to act, by when, and what amount is due.</a:t>
+                <a:spcPts val="600"/>
+              </a:spcAft>
+              <a:defRPr sz="1200">
+                <a:solidFill>
+                  <a:srgbClr val="0F172A"/>
+                </a:solidFill>
+              </a:defRPr>
+            </a:pPr>
+            <a:r>
+              <a:t>•  Google Gemini AI summarizes complex notices into 2 clear sentences.</a:t>
+            </a:r>
+          </a:p>
+          <a:p>
+            <a:pPr>
+              <a:spcAft>
+                <a:spcPts val="600"/>
+              </a:spcAft>
+              <a:defRPr sz="1200">
+                <a:solidFill>
+                  <a:srgbClr val="0F172A"/>
+                </a:solidFill>
+              </a:defRPr>
+            </a:pPr>
+            <a:r>
+              <a:t>•  Smart offline heuristic fallback ensures 100% zero downtime.</a:t>
+            </a:r>
+          </a:p>
+          <a:p>
+            <a:pPr>
+              <a:spcAft>
+                <a:spcPts val="600"/>
+              </a:spcAft>
+              <a:defRPr sz="1200">
+                <a:solidFill>
+                  <a:srgbClr val="0F172A"/>
+                </a:solidFill>
+              </a:defRPr>
+            </a:pPr>
+            <a:r>
+              <a:t>•  Bilingual templates (English + Gujarati) for regional students &amp; parents.</a:t>
+            </a:r>
+          </a:p>
+          <a:p>
+            <a:pPr>
+              <a:spcAft>
+                <a:spcPts val="600"/>
+              </a:spcAft>
+              <a:defRPr sz="1200">
+                <a:solidFill>
+                  <a:srgbClr val="0F172A"/>
+                </a:solidFill>
+              </a:defRPr>
+            </a:pPr>
+            <a:r>
+              <a:t>•  Instantly highlights who needs to act, deadline date, and fee amount.</a:t>
             </a:r>
           </a:p>
         </p:txBody>
@@ -7124,7 +7124,7 @@
         <p:spPr>
           <a:xfrm>
             <a:off x="6190488" y="3822191"/>
-            <a:ext cx="5376672" cy="2514600"/>
+            <a:ext cx="5376672" cy="2542032"/>
           </a:xfrm>
           <a:prstGeom prst="roundRect">
             <a:avLst/>
@@ -7169,7 +7169,7 @@
         <p:spPr>
           <a:xfrm>
             <a:off x="6190488" y="3822191"/>
-            <a:ext cx="5376672" cy="530352"/>
+            <a:ext cx="5376672" cy="475488"/>
           </a:xfrm>
           <a:prstGeom prst="roundRect">
             <a:avLst/>
@@ -7211,8 +7211,8 @@
         </p:nvSpPr>
         <p:spPr>
           <a:xfrm>
-            <a:off x="6373368" y="3877055"/>
-            <a:ext cx="5010912" cy="457200"/>
+            <a:off x="6355080" y="3867911"/>
+            <a:ext cx="5047488" cy="402336"/>
           </a:xfrm>
           <a:prstGeom prst="rect">
             <a:avLst/>
@@ -7226,7 +7226,7 @@
           <a:lstStyle/>
           <a:p>
             <a:pPr>
-              <a:defRPr sz="1550" b="1">
+              <a:defRPr sz="1450" b="1">
                 <a:solidFill>
                   <a:srgbClr val="FFFFFF"/>
                 </a:solidFill>
@@ -7246,8 +7246,8 @@
         </p:nvSpPr>
         <p:spPr>
           <a:xfrm>
-            <a:off x="6373368" y="4462271"/>
-            <a:ext cx="5010912" cy="1801368"/>
+            <a:off x="6355080" y="4370831"/>
+            <a:ext cx="5047488" cy="1938528"/>
           </a:xfrm>
           <a:prstGeom prst="rect">
             <a:avLst/>
@@ -7262,61 +7262,61 @@
           <a:p>
             <a:pPr>
               <a:spcAft>
-                <a:spcPts val="1000"/>
-              </a:spcAft>
-              <a:defRPr sz="1350">
-                <a:solidFill>
-                  <a:srgbClr val="0F172A"/>
-                </a:solidFill>
-              </a:defRPr>
-            </a:pPr>
-            <a:r>
-              <a:t>•  Spoken Daily Voice Bulletin (30-sec MP3 audio briefing) for busy commuters &amp; visually impaired.</a:t>
-            </a:r>
-          </a:p>
-          <a:p>
-            <a:pPr>
-              <a:spcAft>
-                <a:spcPts val="1000"/>
-              </a:spcAft>
-              <a:defRPr sz="1350">
-                <a:solidFill>
-                  <a:srgbClr val="0F172A"/>
-                </a:solidFill>
-              </a:defRPr>
-            </a:pPr>
-            <a:r>
-              <a:t>•  Modern PWA Web Dashboard with Live Search, Dark/Light Theme &amp; Course Filters.</a:t>
-            </a:r>
-          </a:p>
-          <a:p>
-            <a:pPr>
-              <a:spcAft>
-                <a:spcPts val="1000"/>
-              </a:spcAft>
-              <a:defRPr sz="1350">
-                <a:solidFill>
-                  <a:srgbClr val="0F172A"/>
-                </a:solidFill>
-              </a:defRPr>
-            </a:pPr>
-            <a:r>
-              <a:t>•  Service Worker (sw.js) enables 100% offline access to previously loaded notices.</a:t>
-            </a:r>
-          </a:p>
-          <a:p>
-            <a:pPr>
-              <a:spcAft>
-                <a:spcPts val="1000"/>
-              </a:spcAft>
-              <a:defRPr sz="1350">
-                <a:solidFill>
-                  <a:srgbClr val="0F172A"/>
-                </a:solidFill>
-              </a:defRPr>
-            </a:pPr>
-            <a:r>
-              <a:t>•  Zero-Cost Cloud Deployment: Hosted 100% free on GitHub Pages and GitHub Actions.</a:t>
+                <a:spcPts val="600"/>
+              </a:spcAft>
+              <a:defRPr sz="1200">
+                <a:solidFill>
+                  <a:srgbClr val="0F172A"/>
+                </a:solidFill>
+              </a:defRPr>
+            </a:pPr>
+            <a:r>
+              <a:t>•  Daily Voice Bulletin (30-sec MP3 audio briefing) for busy commuters.</a:t>
+            </a:r>
+          </a:p>
+          <a:p>
+            <a:pPr>
+              <a:spcAft>
+                <a:spcPts val="600"/>
+              </a:spcAft>
+              <a:defRPr sz="1200">
+                <a:solidFill>
+                  <a:srgbClr val="0F172A"/>
+                </a:solidFill>
+              </a:defRPr>
+            </a:pPr>
+            <a:r>
+              <a:t>•  Modern PWA Web Dashboard with Live Search &amp; Stream Filters.</a:t>
+            </a:r>
+          </a:p>
+          <a:p>
+            <a:pPr>
+              <a:spcAft>
+                <a:spcPts val="600"/>
+              </a:spcAft>
+              <a:defRPr sz="1200">
+                <a:solidFill>
+                  <a:srgbClr val="0F172A"/>
+                </a:solidFill>
+              </a:defRPr>
+            </a:pPr>
+            <a:r>
+              <a:t>•  Offline Service Worker cache allows viewing without internet.</a:t>
+            </a:r>
+          </a:p>
+          <a:p>
+            <a:pPr>
+              <a:spcAft>
+                <a:spcPts val="600"/>
+              </a:spcAft>
+              <a:defRPr sz="1200">
+                <a:solidFill>
+                  <a:srgbClr val="0F172A"/>
+                </a:solidFill>
+              </a:defRPr>
+            </a:pPr>
+            <a:r>
+              <a:t>•  Zero-Cost Cloud Deployment via GitHub Pages &amp; GitHub Actions.</a:t>
             </a:r>
           </a:p>
         </p:txBody>
@@ -7476,8 +7476,8 @@
         </p:nvSpPr>
         <p:spPr>
           <a:xfrm>
-            <a:off x="7498079" y="164592"/>
-            <a:ext cx="4114800" cy="777240"/>
+            <a:off x="7132320" y="164592"/>
+            <a:ext cx="4480560" cy="777240"/>
           </a:xfrm>
           <a:prstGeom prst="rect">
             <a:avLst/>
@@ -7491,18 +7491,18 @@
           <a:lstStyle/>
           <a:p>
             <a:pPr algn="r">
-              <a:defRPr sz="1100" b="1">
+              <a:defRPr sz="1050" b="1">
                 <a:solidFill>
                   <a:srgbClr val="F97316"/>
                 </a:solidFill>
               </a:defRPr>
             </a:pPr>
             <a:r>
-              <a:t>SMART INDIA HACKATHON 2024</a:t>
+              <a:t>GUJARAT TECHNOLOGICAL UNIVERSITY</a:t>
             </a:r>
             <a:br/>
             <a:r>
-              <a:t>THEME: SMART EDUCATION / AUTOMATION</a:t>
+              <a:t>CAMPUS AUTOMATION &amp; STUDENT WELFARE</a:t>
             </a:r>
           </a:p>
         </p:txBody>
@@ -7516,7 +7516,7 @@
         <p:spPr>
           <a:xfrm>
             <a:off x="594360" y="201168"/>
-            <a:ext cx="6858000" cy="685800"/>
+            <a:ext cx="6583680" cy="685800"/>
           </a:xfrm>
           <a:prstGeom prst="rect">
             <a:avLst/>
@@ -7596,7 +7596,7 @@
         <p:spPr>
           <a:xfrm>
             <a:off x="594360" y="6510528"/>
-            <a:ext cx="7772400" cy="320040"/>
+            <a:ext cx="8046720" cy="320040"/>
           </a:xfrm>
           <a:prstGeom prst="rect">
             <a:avLst/>
@@ -7617,7 +7617,7 @@
               </a:defRPr>
             </a:pPr>
             <a:r>
-              <a:t>SIH 2024  |  Problem: GTU Notice Broadcast Automation  |  Team: GTU Innovators</a:t>
+              <a:t>GTU Circular &amp; Notification Alert System  |  Department of Computer / IT Engineering</a:t>
             </a:r>
           </a:p>
         </p:txBody>
@@ -7711,7 +7711,7 @@
         <p:spPr>
           <a:xfrm>
             <a:off x="594360" y="1234440"/>
-            <a:ext cx="2578608" cy="621792"/>
+            <a:ext cx="2578608" cy="594360"/>
           </a:xfrm>
           <a:prstGeom prst="roundRect">
             <a:avLst/>
@@ -7753,8 +7753,8 @@
         </p:nvSpPr>
         <p:spPr>
           <a:xfrm>
-            <a:off x="777240" y="1289304"/>
-            <a:ext cx="2212848" cy="548640"/>
+            <a:off x="758952" y="1280160"/>
+            <a:ext cx="2249424" cy="521208"/>
           </a:xfrm>
           <a:prstGeom prst="rect">
             <a:avLst/>
@@ -7768,7 +7768,7 @@
           <a:lstStyle/>
           <a:p>
             <a:pPr>
-              <a:defRPr sz="1550" b="1">
+              <a:defRPr sz="1450" b="1">
                 <a:solidFill>
                   <a:srgbClr val="FFFFFF"/>
                 </a:solidFill>
@@ -7780,7 +7780,7 @@
           </a:p>
           <a:p>
             <a:pPr>
-              <a:defRPr sz="1000" b="1">
+              <a:defRPr sz="950" b="1">
                 <a:solidFill>
                   <a:srgbClr val="E0F2FE"/>
                 </a:solidFill>
@@ -7800,8 +7800,8 @@
         </p:nvSpPr>
         <p:spPr>
           <a:xfrm>
-            <a:off x="777240" y="1965960"/>
-            <a:ext cx="2212848" cy="4315968"/>
+            <a:off x="758952" y="1901952"/>
+            <a:ext cx="2249424" cy="4398264"/>
           </a:xfrm>
           <a:prstGeom prst="rect">
             <a:avLst/>
@@ -7816,9 +7816,9 @@
           <a:p>
             <a:pPr>
               <a:spcAft>
-                <a:spcPts val="1100"/>
-              </a:spcAft>
-              <a:defRPr sz="1250">
+                <a:spcPts val="1000"/>
+              </a:spcAft>
+              <a:defRPr sz="1200">
                 <a:solidFill>
                   <a:srgbClr val="0F172A"/>
                 </a:solidFill>
@@ -7831,9 +7831,9 @@
           <a:p>
             <a:pPr>
               <a:spcAft>
-                <a:spcPts val="1100"/>
-              </a:spcAft>
-              <a:defRPr sz="1250">
+                <a:spcPts val="1000"/>
+              </a:spcAft>
+              <a:defRPr sz="1200">
                 <a:solidFill>
                   <a:srgbClr val="0F172A"/>
                 </a:solidFill>
@@ -7846,9 +7846,9 @@
           <a:p>
             <a:pPr>
               <a:spcAft>
-                <a:spcPts val="1100"/>
-              </a:spcAft>
-              <a:defRPr sz="1250">
+                <a:spcPts val="1000"/>
+              </a:spcAft>
+              <a:defRPr sz="1200">
                 <a:solidFill>
                   <a:srgbClr val="0F172A"/>
                 </a:solidFill>
@@ -7861,9 +7861,9 @@
           <a:p>
             <a:pPr>
               <a:spcAft>
-                <a:spcPts val="1100"/>
-              </a:spcAft>
-              <a:defRPr sz="1250">
+                <a:spcPts val="1000"/>
+              </a:spcAft>
+              <a:defRPr sz="1200">
                 <a:solidFill>
                   <a:srgbClr val="0F172A"/>
                 </a:solidFill>
@@ -7876,9 +7876,9 @@
           <a:p>
             <a:pPr>
               <a:spcAft>
-                <a:spcPts val="1100"/>
-              </a:spcAft>
-              <a:defRPr sz="1250">
+                <a:spcPts val="1000"/>
+              </a:spcAft>
+              <a:defRPr sz="1200">
                 <a:solidFill>
                   <a:srgbClr val="0F172A"/>
                 </a:solidFill>
@@ -7891,9 +7891,9 @@
           <a:p>
             <a:pPr>
               <a:spcAft>
-                <a:spcPts val="1100"/>
-              </a:spcAft>
-              <a:defRPr sz="1250">
+                <a:spcPts val="1000"/>
+              </a:spcAft>
+              <a:defRPr sz="1200">
                 <a:solidFill>
                   <a:srgbClr val="0F172A"/>
                 </a:solidFill>
@@ -7906,9 +7906,9 @@
           <a:p>
             <a:pPr>
               <a:spcAft>
-                <a:spcPts val="1100"/>
-              </a:spcAft>
-              <a:defRPr sz="1250">
+                <a:spcPts val="1000"/>
+              </a:spcAft>
+              <a:defRPr sz="1200">
                 <a:solidFill>
                   <a:srgbClr val="0F172A"/>
                 </a:solidFill>
@@ -7974,7 +7974,7 @@
         <p:spPr>
           <a:xfrm>
             <a:off x="3392424" y="1234440"/>
-            <a:ext cx="2578608" cy="621792"/>
+            <a:ext cx="2578608" cy="594360"/>
           </a:xfrm>
           <a:prstGeom prst="roundRect">
             <a:avLst/>
@@ -8016,8 +8016,8 @@
         </p:nvSpPr>
         <p:spPr>
           <a:xfrm>
-            <a:off x="3575304" y="1289304"/>
-            <a:ext cx="2212848" cy="548640"/>
+            <a:off x="3557016" y="1280160"/>
+            <a:ext cx="2249424" cy="521208"/>
           </a:xfrm>
           <a:prstGeom prst="rect">
             <a:avLst/>
@@ -8031,7 +8031,7 @@
           <a:lstStyle/>
           <a:p>
             <a:pPr>
-              <a:defRPr sz="1550" b="1">
+              <a:defRPr sz="1450" b="1">
                 <a:solidFill>
                   <a:srgbClr val="FFFFFF"/>
                 </a:solidFill>
@@ -8043,7 +8043,7 @@
           </a:p>
           <a:p>
             <a:pPr>
-              <a:defRPr sz="1000" b="1">
+              <a:defRPr sz="950" b="1">
                 <a:solidFill>
                   <a:srgbClr val="E0F2FE"/>
                 </a:solidFill>
@@ -8063,8 +8063,8 @@
         </p:nvSpPr>
         <p:spPr>
           <a:xfrm>
-            <a:off x="3575304" y="1965960"/>
-            <a:ext cx="2212848" cy="4315968"/>
+            <a:off x="3557016" y="1901952"/>
+            <a:ext cx="2249424" cy="4398264"/>
           </a:xfrm>
           <a:prstGeom prst="rect">
             <a:avLst/>
@@ -8079,9 +8079,9 @@
           <a:p>
             <a:pPr>
               <a:spcAft>
-                <a:spcPts val="1100"/>
-              </a:spcAft>
-              <a:defRPr sz="1250">
+                <a:spcPts val="1000"/>
+              </a:spcAft>
+              <a:defRPr sz="1200">
                 <a:solidFill>
                   <a:srgbClr val="0F172A"/>
                 </a:solidFill>
@@ -8094,9 +8094,9 @@
           <a:p>
             <a:pPr>
               <a:spcAft>
-                <a:spcPts val="1100"/>
-              </a:spcAft>
-              <a:defRPr sz="1250">
+                <a:spcPts val="1000"/>
+              </a:spcAft>
+              <a:defRPr sz="1200">
                 <a:solidFill>
                   <a:srgbClr val="0F172A"/>
                 </a:solidFill>
@@ -8109,9 +8109,9 @@
           <a:p>
             <a:pPr>
               <a:spcAft>
-                <a:spcPts val="1100"/>
-              </a:spcAft>
-              <a:defRPr sz="1250">
+                <a:spcPts val="1000"/>
+              </a:spcAft>
+              <a:defRPr sz="1200">
                 <a:solidFill>
                   <a:srgbClr val="0F172A"/>
                 </a:solidFill>
@@ -8124,9 +8124,9 @@
           <a:p>
             <a:pPr>
               <a:spcAft>
-                <a:spcPts val="1100"/>
-              </a:spcAft>
-              <a:defRPr sz="1250">
+                <a:spcPts val="1000"/>
+              </a:spcAft>
+              <a:defRPr sz="1200">
                 <a:solidFill>
                   <a:srgbClr val="0F172A"/>
                 </a:solidFill>
@@ -8139,9 +8139,9 @@
           <a:p>
             <a:pPr>
               <a:spcAft>
-                <a:spcPts val="1100"/>
-              </a:spcAft>
-              <a:defRPr sz="1250">
+                <a:spcPts val="1000"/>
+              </a:spcAft>
+              <a:defRPr sz="1200">
                 <a:solidFill>
                   <a:srgbClr val="0F172A"/>
                 </a:solidFill>
@@ -8154,9 +8154,9 @@
           <a:p>
             <a:pPr>
               <a:spcAft>
-                <a:spcPts val="1100"/>
-              </a:spcAft>
-              <a:defRPr sz="1250">
+                <a:spcPts val="1000"/>
+              </a:spcAft>
+              <a:defRPr sz="1200">
                 <a:solidFill>
                   <a:srgbClr val="0F172A"/>
                 </a:solidFill>
@@ -8169,9 +8169,9 @@
           <a:p>
             <a:pPr>
               <a:spcAft>
-                <a:spcPts val="1100"/>
-              </a:spcAft>
-              <a:defRPr sz="1250">
+                <a:spcPts val="1000"/>
+              </a:spcAft>
+              <a:defRPr sz="1200">
                 <a:solidFill>
                   <a:srgbClr val="0F172A"/>
                 </a:solidFill>
@@ -8237,7 +8237,7 @@
         <p:spPr>
           <a:xfrm>
             <a:off x="6190488" y="1234440"/>
-            <a:ext cx="2578608" cy="621792"/>
+            <a:ext cx="2578608" cy="594360"/>
           </a:xfrm>
           <a:prstGeom prst="roundRect">
             <a:avLst/>
@@ -8279,8 +8279,8 @@
         </p:nvSpPr>
         <p:spPr>
           <a:xfrm>
-            <a:off x="6373368" y="1289304"/>
-            <a:ext cx="2212848" cy="548640"/>
+            <a:off x="6355080" y="1280160"/>
+            <a:ext cx="2249424" cy="521208"/>
           </a:xfrm>
           <a:prstGeom prst="rect">
             <a:avLst/>
@@ -8294,7 +8294,7 @@
           <a:lstStyle/>
           <a:p>
             <a:pPr>
-              <a:defRPr sz="1550" b="1">
+              <a:defRPr sz="1450" b="1">
                 <a:solidFill>
                   <a:srgbClr val="FFFFFF"/>
                 </a:solidFill>
@@ -8306,7 +8306,7 @@
           </a:p>
           <a:p>
             <a:pPr>
-              <a:defRPr sz="1000" b="1">
+              <a:defRPr sz="950" b="1">
                 <a:solidFill>
                   <a:srgbClr val="E0F2FE"/>
                 </a:solidFill>
@@ -8326,8 +8326,8 @@
         </p:nvSpPr>
         <p:spPr>
           <a:xfrm>
-            <a:off x="6373368" y="1965960"/>
-            <a:ext cx="2212848" cy="4315968"/>
+            <a:off x="6355080" y="1901952"/>
+            <a:ext cx="2249424" cy="4398264"/>
           </a:xfrm>
           <a:prstGeom prst="rect">
             <a:avLst/>
@@ -8342,9 +8342,9 @@
           <a:p>
             <a:pPr>
               <a:spcAft>
-                <a:spcPts val="1100"/>
-              </a:spcAft>
-              <a:defRPr sz="1250">
+                <a:spcPts val="1000"/>
+              </a:spcAft>
+              <a:defRPr sz="1200">
                 <a:solidFill>
                   <a:srgbClr val="0F172A"/>
                 </a:solidFill>
@@ -8357,9 +8357,9 @@
           <a:p>
             <a:pPr>
               <a:spcAft>
-                <a:spcPts val="1100"/>
-              </a:spcAft>
-              <a:defRPr sz="1250">
+                <a:spcPts val="1000"/>
+              </a:spcAft>
+              <a:defRPr sz="1200">
                 <a:solidFill>
                   <a:srgbClr val="0F172A"/>
                 </a:solidFill>
@@ -8372,9 +8372,9 @@
           <a:p>
             <a:pPr>
               <a:spcAft>
-                <a:spcPts val="1100"/>
-              </a:spcAft>
-              <a:defRPr sz="1250">
+                <a:spcPts val="1000"/>
+              </a:spcAft>
+              <a:defRPr sz="1200">
                 <a:solidFill>
                   <a:srgbClr val="0F172A"/>
                 </a:solidFill>
@@ -8387,9 +8387,9 @@
           <a:p>
             <a:pPr>
               <a:spcAft>
-                <a:spcPts val="1100"/>
-              </a:spcAft>
-              <a:defRPr sz="1250">
+                <a:spcPts val="1000"/>
+              </a:spcAft>
+              <a:defRPr sz="1200">
                 <a:solidFill>
                   <a:srgbClr val="0F172A"/>
                 </a:solidFill>
@@ -8402,9 +8402,9 @@
           <a:p>
             <a:pPr>
               <a:spcAft>
-                <a:spcPts val="1100"/>
-              </a:spcAft>
-              <a:defRPr sz="1250">
+                <a:spcPts val="1000"/>
+              </a:spcAft>
+              <a:defRPr sz="1200">
                 <a:solidFill>
                   <a:srgbClr val="0F172A"/>
                 </a:solidFill>
@@ -8417,9 +8417,9 @@
           <a:p>
             <a:pPr>
               <a:spcAft>
-                <a:spcPts val="1100"/>
-              </a:spcAft>
-              <a:defRPr sz="1250">
+                <a:spcPts val="1000"/>
+              </a:spcAft>
+              <a:defRPr sz="1200">
                 <a:solidFill>
                   <a:srgbClr val="0F172A"/>
                 </a:solidFill>
@@ -8432,9 +8432,9 @@
           <a:p>
             <a:pPr>
               <a:spcAft>
-                <a:spcPts val="1100"/>
-              </a:spcAft>
-              <a:defRPr sz="1250">
+                <a:spcPts val="1000"/>
+              </a:spcAft>
+              <a:defRPr sz="1200">
                 <a:solidFill>
                   <a:srgbClr val="0F172A"/>
                 </a:solidFill>
@@ -8500,7 +8500,7 @@
         <p:spPr>
           <a:xfrm>
             <a:off x="8988552" y="1234440"/>
-            <a:ext cx="2578608" cy="621792"/>
+            <a:ext cx="2578608" cy="594360"/>
           </a:xfrm>
           <a:prstGeom prst="roundRect">
             <a:avLst/>
@@ -8542,8 +8542,8 @@
         </p:nvSpPr>
         <p:spPr>
           <a:xfrm>
-            <a:off x="9171432" y="1289304"/>
-            <a:ext cx="2212848" cy="548640"/>
+            <a:off x="9153144" y="1280160"/>
+            <a:ext cx="2249424" cy="521208"/>
           </a:xfrm>
           <a:prstGeom prst="rect">
             <a:avLst/>
@@ -8557,7 +8557,7 @@
           <a:lstStyle/>
           <a:p>
             <a:pPr>
-              <a:defRPr sz="1550" b="1">
+              <a:defRPr sz="1450" b="1">
                 <a:solidFill>
                   <a:srgbClr val="FFFFFF"/>
                 </a:solidFill>
@@ -8569,7 +8569,7 @@
           </a:p>
           <a:p>
             <a:pPr>
-              <a:defRPr sz="1000" b="1">
+              <a:defRPr sz="950" b="1">
                 <a:solidFill>
                   <a:srgbClr val="E0F2FE"/>
                 </a:solidFill>
@@ -8589,8 +8589,8 @@
         </p:nvSpPr>
         <p:spPr>
           <a:xfrm>
-            <a:off x="9171432" y="1965960"/>
-            <a:ext cx="2212848" cy="4315968"/>
+            <a:off x="9153144" y="1901952"/>
+            <a:ext cx="2249424" cy="4398264"/>
           </a:xfrm>
           <a:prstGeom prst="rect">
             <a:avLst/>
@@ -8605,9 +8605,9 @@
           <a:p>
             <a:pPr>
               <a:spcAft>
-                <a:spcPts val="1100"/>
-              </a:spcAft>
-              <a:defRPr sz="1250">
+                <a:spcPts val="1000"/>
+              </a:spcAft>
+              <a:defRPr sz="1200">
                 <a:solidFill>
                   <a:srgbClr val="0F172A"/>
                 </a:solidFill>
@@ -8620,9 +8620,9 @@
           <a:p>
             <a:pPr>
               <a:spcAft>
-                <a:spcPts val="1100"/>
-              </a:spcAft>
-              <a:defRPr sz="1250">
+                <a:spcPts val="1000"/>
+              </a:spcAft>
+              <a:defRPr sz="1200">
                 <a:solidFill>
                   <a:srgbClr val="0F172A"/>
                 </a:solidFill>
@@ -8635,9 +8635,9 @@
           <a:p>
             <a:pPr>
               <a:spcAft>
-                <a:spcPts val="1100"/>
-              </a:spcAft>
-              <a:defRPr sz="1250">
+                <a:spcPts val="1000"/>
+              </a:spcAft>
+              <a:defRPr sz="1200">
                 <a:solidFill>
                   <a:srgbClr val="0F172A"/>
                 </a:solidFill>
@@ -8650,9 +8650,9 @@
           <a:p>
             <a:pPr>
               <a:spcAft>
-                <a:spcPts val="1100"/>
-              </a:spcAft>
-              <a:defRPr sz="1250">
+                <a:spcPts val="1000"/>
+              </a:spcAft>
+              <a:defRPr sz="1200">
                 <a:solidFill>
                   <a:srgbClr val="0F172A"/>
                 </a:solidFill>
@@ -8665,9 +8665,9 @@
           <a:p>
             <a:pPr>
               <a:spcAft>
-                <a:spcPts val="1100"/>
-              </a:spcAft>
-              <a:defRPr sz="1250">
+                <a:spcPts val="1000"/>
+              </a:spcAft>
+              <a:defRPr sz="1200">
                 <a:solidFill>
                   <a:srgbClr val="0F172A"/>
                 </a:solidFill>
@@ -8680,9 +8680,9 @@
           <a:p>
             <a:pPr>
               <a:spcAft>
-                <a:spcPts val="1100"/>
-              </a:spcAft>
-              <a:defRPr sz="1250">
+                <a:spcPts val="1000"/>
+              </a:spcAft>
+              <a:defRPr sz="1200">
                 <a:solidFill>
                   <a:srgbClr val="0F172A"/>
                 </a:solidFill>
@@ -8695,9 +8695,9 @@
           <a:p>
             <a:pPr>
               <a:spcAft>
-                <a:spcPts val="1100"/>
-              </a:spcAft>
-              <a:defRPr sz="1250">
+                <a:spcPts val="1000"/>
+              </a:spcAft>
+              <a:defRPr sz="1200">
                 <a:solidFill>
                   <a:srgbClr val="0F172A"/>
                 </a:solidFill>
@@ -8864,8 +8864,8 @@
         </p:nvSpPr>
         <p:spPr>
           <a:xfrm>
-            <a:off x="7498079" y="164592"/>
-            <a:ext cx="4114800" cy="777240"/>
+            <a:off x="7132320" y="164592"/>
+            <a:ext cx="4480560" cy="777240"/>
           </a:xfrm>
           <a:prstGeom prst="rect">
             <a:avLst/>
@@ -8879,18 +8879,18 @@
           <a:lstStyle/>
           <a:p>
             <a:pPr algn="r">
-              <a:defRPr sz="1100" b="1">
+              <a:defRPr sz="1050" b="1">
                 <a:solidFill>
                   <a:srgbClr val="F97316"/>
                 </a:solidFill>
               </a:defRPr>
             </a:pPr>
             <a:r>
-              <a:t>SMART INDIA HACKATHON 2024</a:t>
+              <a:t>GUJARAT TECHNOLOGICAL UNIVERSITY</a:t>
             </a:r>
             <a:br/>
             <a:r>
-              <a:t>THEME: SMART EDUCATION / AUTOMATION</a:t>
+              <a:t>CAMPUS AUTOMATION &amp; STUDENT WELFARE</a:t>
             </a:r>
           </a:p>
         </p:txBody>
@@ -8904,7 +8904,7 @@
         <p:spPr>
           <a:xfrm>
             <a:off x="594360" y="201168"/>
-            <a:ext cx="6858000" cy="685800"/>
+            <a:ext cx="6583680" cy="685800"/>
           </a:xfrm>
           <a:prstGeom prst="rect">
             <a:avLst/>
@@ -8984,7 +8984,7 @@
         <p:spPr>
           <a:xfrm>
             <a:off x="594360" y="6510528"/>
-            <a:ext cx="7772400" cy="320040"/>
+            <a:ext cx="8046720" cy="320040"/>
           </a:xfrm>
           <a:prstGeom prst="rect">
             <a:avLst/>
@@ -9005,7 +9005,7 @@
               </a:defRPr>
             </a:pPr>
             <a:r>
-              <a:t>SIH 2024  |  Problem: GTU Notice Broadcast Automation  |  Team: GTU Innovators</a:t>
+              <a:t>GTU Circular &amp; Notification Alert System  |  Department of Computer / IT Engineering</a:t>
             </a:r>
           </a:p>
         </p:txBody>
@@ -9099,7 +9099,7 @@
         <p:spPr>
           <a:xfrm>
             <a:off x="594360" y="1234440"/>
-            <a:ext cx="5376672" cy="621792"/>
+            <a:ext cx="5376672" cy="594360"/>
           </a:xfrm>
           <a:prstGeom prst="roundRect">
             <a:avLst/>
@@ -9141,8 +9141,8 @@
         </p:nvSpPr>
         <p:spPr>
           <a:xfrm>
-            <a:off x="777240" y="1289304"/>
-            <a:ext cx="5010912" cy="548640"/>
+            <a:off x="758952" y="1280160"/>
+            <a:ext cx="5047488" cy="521208"/>
           </a:xfrm>
           <a:prstGeom prst="rect">
             <a:avLst/>
@@ -9156,7 +9156,7 @@
           <a:lstStyle/>
           <a:p>
             <a:pPr>
-              <a:defRPr sz="1550" b="1">
+              <a:defRPr sz="1450" b="1">
                 <a:solidFill>
                   <a:srgbClr val="FFFFFF"/>
                 </a:solidFill>
@@ -9168,7 +9168,7 @@
           </a:p>
           <a:p>
             <a:pPr>
-              <a:defRPr sz="1000" b="1">
+              <a:defRPr sz="950" b="1">
                 <a:solidFill>
                   <a:srgbClr val="E0F2FE"/>
                 </a:solidFill>
@@ -9188,8 +9188,8 @@
         </p:nvSpPr>
         <p:spPr>
           <a:xfrm>
-            <a:off x="777240" y="1965960"/>
-            <a:ext cx="5010912" cy="4315968"/>
+            <a:off x="758952" y="1901952"/>
+            <a:ext cx="5047488" cy="4398264"/>
           </a:xfrm>
           <a:prstGeom prst="rect">
             <a:avLst/>
@@ -9204,9 +9204,9 @@
           <a:p>
             <a:pPr>
               <a:spcAft>
-                <a:spcPts val="900"/>
-              </a:spcAft>
-              <a:defRPr sz="1300">
+                <a:spcPts val="800"/>
+              </a:spcAft>
+              <a:defRPr sz="1250">
                 <a:solidFill>
                   <a:srgbClr val="0F172A"/>
                 </a:solidFill>
@@ -9219,9 +9219,9 @@
           <a:p>
             <a:pPr>
               <a:spcAft>
-                <a:spcPts val="900"/>
-              </a:spcAft>
-              <a:defRPr sz="1300">
+                <a:spcPts val="800"/>
+              </a:spcAft>
+              <a:defRPr sz="1250">
                 <a:solidFill>
                   <a:srgbClr val="0F172A"/>
                 </a:solidFill>
@@ -9234,9 +9234,9 @@
           <a:p>
             <a:pPr>
               <a:spcAft>
-                <a:spcPts val="900"/>
-              </a:spcAft>
-              <a:defRPr sz="1300">
+                <a:spcPts val="800"/>
+              </a:spcAft>
+              <a:defRPr sz="1250">
                 <a:solidFill>
                   <a:srgbClr val="0F172A"/>
                 </a:solidFill>
@@ -9249,9 +9249,9 @@
           <a:p>
             <a:pPr>
               <a:spcAft>
-                <a:spcPts val="900"/>
-              </a:spcAft>
-              <a:defRPr sz="1300">
+                <a:spcPts val="800"/>
+              </a:spcAft>
+              <a:defRPr sz="1250">
                 <a:solidFill>
                   <a:srgbClr val="0F172A"/>
                 </a:solidFill>
@@ -9264,9 +9264,9 @@
           <a:p>
             <a:pPr>
               <a:spcAft>
-                <a:spcPts val="900"/>
-              </a:spcAft>
-              <a:defRPr sz="1300">
+                <a:spcPts val="800"/>
+              </a:spcAft>
+              <a:defRPr sz="1250">
                 <a:solidFill>
                   <a:srgbClr val="0F172A"/>
                 </a:solidFill>
@@ -9279,9 +9279,9 @@
           <a:p>
             <a:pPr>
               <a:spcAft>
-                <a:spcPts val="900"/>
-              </a:spcAft>
-              <a:defRPr sz="1300">
+                <a:spcPts val="800"/>
+              </a:spcAft>
+              <a:defRPr sz="1250">
                 <a:solidFill>
                   <a:srgbClr val="0F172A"/>
                 </a:solidFill>
@@ -9294,9 +9294,9 @@
           <a:p>
             <a:pPr>
               <a:spcAft>
-                <a:spcPts val="900"/>
-              </a:spcAft>
-              <a:defRPr sz="1300">
+                <a:spcPts val="800"/>
+              </a:spcAft>
+              <a:defRPr sz="1250">
                 <a:solidFill>
                   <a:srgbClr val="0F172A"/>
                 </a:solidFill>
@@ -9309,9 +9309,9 @@
           <a:p>
             <a:pPr>
               <a:spcAft>
-                <a:spcPts val="900"/>
-              </a:spcAft>
-              <a:defRPr sz="1300">
+                <a:spcPts val="800"/>
+              </a:spcAft>
+              <a:defRPr sz="1250">
                 <a:solidFill>
                   <a:srgbClr val="0F172A"/>
                 </a:solidFill>
@@ -9324,9 +9324,9 @@
           <a:p>
             <a:pPr>
               <a:spcAft>
-                <a:spcPts val="900"/>
-              </a:spcAft>
-              <a:defRPr sz="1300">
+                <a:spcPts val="800"/>
+              </a:spcAft>
+              <a:defRPr sz="1250">
                 <a:solidFill>
                   <a:srgbClr val="0F172A"/>
                 </a:solidFill>
@@ -9339,9 +9339,9 @@
           <a:p>
             <a:pPr>
               <a:spcAft>
-                <a:spcPts val="900"/>
-              </a:spcAft>
-              <a:defRPr sz="1300">
+                <a:spcPts val="800"/>
+              </a:spcAft>
+              <a:defRPr sz="1250">
                 <a:solidFill>
                   <a:srgbClr val="0F172A"/>
                 </a:solidFill>
@@ -9407,7 +9407,7 @@
         <p:spPr>
           <a:xfrm>
             <a:off x="6190488" y="1234440"/>
-            <a:ext cx="5376672" cy="621792"/>
+            <a:ext cx="5376672" cy="594360"/>
           </a:xfrm>
           <a:prstGeom prst="roundRect">
             <a:avLst/>
@@ -9449,8 +9449,8 @@
         </p:nvSpPr>
         <p:spPr>
           <a:xfrm>
-            <a:off x="6373368" y="1289304"/>
-            <a:ext cx="5010912" cy="548640"/>
+            <a:off x="6355080" y="1280160"/>
+            <a:ext cx="5047488" cy="521208"/>
           </a:xfrm>
           <a:prstGeom prst="rect">
             <a:avLst/>
@@ -9464,7 +9464,7 @@
           <a:lstStyle/>
           <a:p>
             <a:pPr>
-              <a:defRPr sz="1550" b="1">
+              <a:defRPr sz="1450" b="1">
                 <a:solidFill>
                   <a:srgbClr val="FFFFFF"/>
                 </a:solidFill>
@@ -9476,7 +9476,7 @@
           </a:p>
           <a:p>
             <a:pPr>
-              <a:defRPr sz="1000" b="1">
+              <a:defRPr sz="950" b="1">
                 <a:solidFill>
                   <a:srgbClr val="E0F2FE"/>
                 </a:solidFill>
@@ -9496,8 +9496,8 @@
         </p:nvSpPr>
         <p:spPr>
           <a:xfrm>
-            <a:off x="6373368" y="1965960"/>
-            <a:ext cx="5010912" cy="4315968"/>
+            <a:off x="6355080" y="1901952"/>
+            <a:ext cx="5047488" cy="4398264"/>
           </a:xfrm>
           <a:prstGeom prst="rect">
             <a:avLst/>
@@ -9512,9 +9512,9 @@
           <a:p>
             <a:pPr>
               <a:spcAft>
-                <a:spcPts val="900"/>
-              </a:spcAft>
-              <a:defRPr sz="1300">
+                <a:spcPts val="800"/>
+              </a:spcAft>
+              <a:defRPr sz="1250">
                 <a:solidFill>
                   <a:srgbClr val="0F172A"/>
                 </a:solidFill>
@@ -9527,9 +9527,9 @@
           <a:p>
             <a:pPr>
               <a:spcAft>
-                <a:spcPts val="900"/>
-              </a:spcAft>
-              <a:defRPr sz="1300">
+                <a:spcPts val="800"/>
+              </a:spcAft>
+              <a:defRPr sz="1250">
                 <a:solidFill>
                   <a:srgbClr val="0F172A"/>
                 </a:solidFill>
@@ -9542,9 +9542,9 @@
           <a:p>
             <a:pPr>
               <a:spcAft>
-                <a:spcPts val="900"/>
-              </a:spcAft>
-              <a:defRPr sz="1300">
+                <a:spcPts val="800"/>
+              </a:spcAft>
+              <a:defRPr sz="1250">
                 <a:solidFill>
                   <a:srgbClr val="0F172A"/>
                 </a:solidFill>
@@ -9557,24 +9557,24 @@
           <a:p>
             <a:pPr>
               <a:spcAft>
-                <a:spcPts val="900"/>
-              </a:spcAft>
-              <a:defRPr sz="1300">
-                <a:solidFill>
-                  <a:srgbClr val="0F172A"/>
-                </a:solidFill>
-              </a:defRPr>
-            </a:pPr>
-            <a:r>
-              <a:t>•  Unique Feature 1: Spoken Daily Voice Bulletin (No other university app offers audio news).</a:t>
-            </a:r>
-          </a:p>
-          <a:p>
-            <a:pPr>
-              <a:spcAft>
-                <a:spcPts val="900"/>
-              </a:spcAft>
-              <a:defRPr sz="1300">
+                <a:spcPts val="800"/>
+              </a:spcAft>
+              <a:defRPr sz="1250">
+                <a:solidFill>
+                  <a:srgbClr val="0F172A"/>
+                </a:solidFill>
+              </a:defRPr>
+            </a:pPr>
+            <a:r>
+              <a:t>•  Unique Feature 1: Spoken Daily Voice Bulletin (audio news for accessibility).</a:t>
+            </a:r>
+          </a:p>
+          <a:p>
+            <a:pPr>
+              <a:spcAft>
+                <a:spcPts val="800"/>
+              </a:spcAft>
+              <a:defRPr sz="1250">
                 <a:solidFill>
                   <a:srgbClr val="0F172A"/>
                 </a:solidFill>
@@ -9587,9 +9587,9 @@
           <a:p>
             <a:pPr>
               <a:spcAft>
-                <a:spcPts val="900"/>
-              </a:spcAft>
-              <a:defRPr sz="1300">
+                <a:spcPts val="800"/>
+              </a:spcAft>
+              <a:defRPr sz="1250">
                 <a:solidFill>
                   <a:srgbClr val="0F172A"/>
                 </a:solidFill>
@@ -9602,9 +9602,9 @@
           <a:p>
             <a:pPr>
               <a:spcAft>
-                <a:spcPts val="900"/>
-              </a:spcAft>
-              <a:defRPr sz="1300">
+                <a:spcPts val="800"/>
+              </a:spcAft>
+              <a:defRPr sz="1250">
                 <a:solidFill>
                   <a:srgbClr val="0F172A"/>
                 </a:solidFill>
@@ -9617,9 +9617,9 @@
           <a:p>
             <a:pPr>
               <a:spcAft>
-                <a:spcPts val="900"/>
-              </a:spcAft>
-              <a:defRPr sz="1300">
+                <a:spcPts val="800"/>
+              </a:spcAft>
+              <a:defRPr sz="1250">
                 <a:solidFill>
                   <a:srgbClr val="0F172A"/>
                 </a:solidFill>
@@ -9786,8 +9786,8 @@
         </p:nvSpPr>
         <p:spPr>
           <a:xfrm>
-            <a:off x="7498079" y="164592"/>
-            <a:ext cx="4114800" cy="777240"/>
+            <a:off x="7132320" y="164592"/>
+            <a:ext cx="4480560" cy="777240"/>
           </a:xfrm>
           <a:prstGeom prst="rect">
             <a:avLst/>
@@ -9801,18 +9801,18 @@
           <a:lstStyle/>
           <a:p>
             <a:pPr algn="r">
-              <a:defRPr sz="1100" b="1">
+              <a:defRPr sz="1050" b="1">
                 <a:solidFill>
                   <a:srgbClr val="F97316"/>
                 </a:solidFill>
               </a:defRPr>
             </a:pPr>
             <a:r>
-              <a:t>SMART INDIA HACKATHON 2024</a:t>
+              <a:t>GUJARAT TECHNOLOGICAL UNIVERSITY</a:t>
             </a:r>
             <a:br/>
             <a:r>
-              <a:t>THEME: SMART EDUCATION / AUTOMATION</a:t>
+              <a:t>CAMPUS AUTOMATION &amp; STUDENT WELFARE</a:t>
             </a:r>
           </a:p>
         </p:txBody>
@@ -9826,7 +9826,7 @@
         <p:spPr>
           <a:xfrm>
             <a:off x="594360" y="201168"/>
-            <a:ext cx="6858000" cy="685800"/>
+            <a:ext cx="6583680" cy="685800"/>
           </a:xfrm>
           <a:prstGeom prst="rect">
             <a:avLst/>
@@ -9906,7 +9906,7 @@
         <p:spPr>
           <a:xfrm>
             <a:off x="594360" y="6510528"/>
-            <a:ext cx="7772400" cy="320040"/>
+            <a:ext cx="8046720" cy="320040"/>
           </a:xfrm>
           <a:prstGeom prst="rect">
             <a:avLst/>
@@ -9927,7 +9927,7 @@
               </a:defRPr>
             </a:pPr>
             <a:r>
-              <a:t>SIH 2024  |  Problem: GTU Notice Broadcast Automation  |  Team: GTU Innovators</a:t>
+              <a:t>GTU Circular &amp; Notification Alert System  |  Department of Computer / IT Engineering</a:t>
             </a:r>
           </a:p>
         </p:txBody>
@@ -10021,7 +10021,7 @@
         <p:spPr>
           <a:xfrm>
             <a:off x="594360" y="1234440"/>
-            <a:ext cx="5376672" cy="621792"/>
+            <a:ext cx="5376672" cy="594360"/>
           </a:xfrm>
           <a:prstGeom prst="roundRect">
             <a:avLst/>
@@ -10063,8 +10063,8 @@
         </p:nvSpPr>
         <p:spPr>
           <a:xfrm>
-            <a:off x="777240" y="1289304"/>
-            <a:ext cx="5010912" cy="548640"/>
+            <a:off x="758952" y="1280160"/>
+            <a:ext cx="5047488" cy="521208"/>
           </a:xfrm>
           <a:prstGeom prst="rect">
             <a:avLst/>
@@ -10078,7 +10078,7 @@
           <a:lstStyle/>
           <a:p>
             <a:pPr>
-              <a:defRPr sz="1550" b="1">
+              <a:defRPr sz="1450" b="1">
                 <a:solidFill>
                   <a:srgbClr val="FFFFFF"/>
                 </a:solidFill>
@@ -10090,7 +10090,7 @@
           </a:p>
           <a:p>
             <a:pPr>
-              <a:defRPr sz="1000" b="1">
+              <a:defRPr sz="950" b="1">
                 <a:solidFill>
                   <a:srgbClr val="E0F2FE"/>
                 </a:solidFill>
@@ -10110,8 +10110,8 @@
         </p:nvSpPr>
         <p:spPr>
           <a:xfrm>
-            <a:off x="777240" y="1965960"/>
-            <a:ext cx="5010912" cy="4315968"/>
+            <a:off x="758952" y="1901952"/>
+            <a:ext cx="5047488" cy="4398264"/>
           </a:xfrm>
           <a:prstGeom prst="rect">
             <a:avLst/>
@@ -10126,9 +10126,9 @@
           <a:p>
             <a:pPr>
               <a:spcAft>
-                <a:spcPts val="1000"/>
-              </a:spcAft>
-              <a:defRPr sz="1300">
+                <a:spcPts val="900"/>
+              </a:spcAft>
+              <a:defRPr sz="1250">
                 <a:solidFill>
                   <a:srgbClr val="0F172A"/>
                 </a:solidFill>
@@ -10141,9 +10141,9 @@
           <a:p>
             <a:pPr>
               <a:spcAft>
-                <a:spcPts val="1000"/>
-              </a:spcAft>
-              <a:defRPr sz="1300">
+                <a:spcPts val="900"/>
+              </a:spcAft>
+              <a:defRPr sz="1250">
                 <a:solidFill>
                   <a:srgbClr val="0F172A"/>
                 </a:solidFill>
@@ -10156,9 +10156,9 @@
           <a:p>
             <a:pPr>
               <a:spcAft>
-                <a:spcPts val="1000"/>
-              </a:spcAft>
-              <a:defRPr sz="1300">
+                <a:spcPts val="900"/>
+              </a:spcAft>
+              <a:defRPr sz="1250">
                 <a:solidFill>
                   <a:srgbClr val="0F172A"/>
                 </a:solidFill>
@@ -10171,9 +10171,9 @@
           <a:p>
             <a:pPr>
               <a:spcAft>
-                <a:spcPts val="1000"/>
-              </a:spcAft>
-              <a:defRPr sz="1300">
+                <a:spcPts val="900"/>
+              </a:spcAft>
+              <a:defRPr sz="1250">
                 <a:solidFill>
                   <a:srgbClr val="0F172A"/>
                 </a:solidFill>
@@ -10186,9 +10186,9 @@
           <a:p>
             <a:pPr>
               <a:spcAft>
-                <a:spcPts val="1000"/>
-              </a:spcAft>
-              <a:defRPr sz="1300">
+                <a:spcPts val="900"/>
+              </a:spcAft>
+              <a:defRPr sz="1250">
                 <a:solidFill>
                   <a:srgbClr val="0F172A"/>
                 </a:solidFill>
@@ -10201,9 +10201,9 @@
           <a:p>
             <a:pPr>
               <a:spcAft>
-                <a:spcPts val="1000"/>
-              </a:spcAft>
-              <a:defRPr sz="1300">
+                <a:spcPts val="900"/>
+              </a:spcAft>
+              <a:defRPr sz="1250">
                 <a:solidFill>
                   <a:srgbClr val="0F172A"/>
                 </a:solidFill>
@@ -10216,9 +10216,9 @@
           <a:p>
             <a:pPr>
               <a:spcAft>
-                <a:spcPts val="1000"/>
-              </a:spcAft>
-              <a:defRPr sz="1300">
+                <a:spcPts val="900"/>
+              </a:spcAft>
+              <a:defRPr sz="1250">
                 <a:solidFill>
                   <a:srgbClr val="0F172A"/>
                 </a:solidFill>
@@ -10231,9 +10231,9 @@
           <a:p>
             <a:pPr>
               <a:spcAft>
-                <a:spcPts val="1000"/>
-              </a:spcAft>
-              <a:defRPr sz="1300">
+                <a:spcPts val="900"/>
+              </a:spcAft>
+              <a:defRPr sz="1250">
                 <a:solidFill>
                   <a:srgbClr val="0F172A"/>
                 </a:solidFill>
@@ -10299,7 +10299,7 @@
         <p:spPr>
           <a:xfrm>
             <a:off x="6190488" y="1234440"/>
-            <a:ext cx="5376672" cy="621792"/>
+            <a:ext cx="5376672" cy="594360"/>
           </a:xfrm>
           <a:prstGeom prst="roundRect">
             <a:avLst/>
@@ -10341,8 +10341,8 @@
         </p:nvSpPr>
         <p:spPr>
           <a:xfrm>
-            <a:off x="6373368" y="1289304"/>
-            <a:ext cx="5010912" cy="548640"/>
+            <a:off x="6355080" y="1280160"/>
+            <a:ext cx="5047488" cy="521208"/>
           </a:xfrm>
           <a:prstGeom prst="rect">
             <a:avLst/>
@@ -10356,7 +10356,7 @@
           <a:lstStyle/>
           <a:p>
             <a:pPr>
-              <a:defRPr sz="1550" b="1">
+              <a:defRPr sz="1450" b="1">
                 <a:solidFill>
                   <a:srgbClr val="FFFFFF"/>
                 </a:solidFill>
@@ -10368,7 +10368,7 @@
           </a:p>
           <a:p>
             <a:pPr>
-              <a:defRPr sz="1000" b="1">
+              <a:defRPr sz="950" b="1">
                 <a:solidFill>
                   <a:srgbClr val="E0F2FE"/>
                 </a:solidFill>
@@ -10388,8 +10388,8 @@
         </p:nvSpPr>
         <p:spPr>
           <a:xfrm>
-            <a:off x="6373368" y="1965960"/>
-            <a:ext cx="5010912" cy="4315968"/>
+            <a:off x="6355080" y="1901952"/>
+            <a:ext cx="5047488" cy="4398264"/>
           </a:xfrm>
           <a:prstGeom prst="rect">
             <a:avLst/>
@@ -10404,9 +10404,9 @@
           <a:p>
             <a:pPr>
               <a:spcAft>
-                <a:spcPts val="1000"/>
-              </a:spcAft>
-              <a:defRPr sz="1300">
+                <a:spcPts val="900"/>
+              </a:spcAft>
+              <a:defRPr sz="1250">
                 <a:solidFill>
                   <a:srgbClr val="0F172A"/>
                 </a:solidFill>
@@ -10419,9 +10419,9 @@
           <a:p>
             <a:pPr>
               <a:spcAft>
-                <a:spcPts val="1000"/>
-              </a:spcAft>
-              <a:defRPr sz="1300">
+                <a:spcPts val="900"/>
+              </a:spcAft>
+              <a:defRPr sz="1250">
                 <a:solidFill>
                   <a:srgbClr val="0F172A"/>
                 </a:solidFill>
@@ -10434,9 +10434,9 @@
           <a:p>
             <a:pPr>
               <a:spcAft>
-                <a:spcPts val="1000"/>
-              </a:spcAft>
-              <a:defRPr sz="1300">
+                <a:spcPts val="900"/>
+              </a:spcAft>
+              <a:defRPr sz="1250">
                 <a:solidFill>
                   <a:srgbClr val="0F172A"/>
                 </a:solidFill>
@@ -10449,9 +10449,9 @@
           <a:p>
             <a:pPr>
               <a:spcAft>
-                <a:spcPts val="1000"/>
-              </a:spcAft>
-              <a:defRPr sz="1300">
+                <a:spcPts val="900"/>
+              </a:spcAft>
+              <a:defRPr sz="1250">
                 <a:solidFill>
                   <a:srgbClr val="0F172A"/>
                 </a:solidFill>
@@ -10464,24 +10464,24 @@
           <a:p>
             <a:pPr>
               <a:spcAft>
-                <a:spcPts val="1000"/>
-              </a:spcAft>
-              <a:defRPr sz="1300">
-                <a:solidFill>
-                  <a:srgbClr val="0F172A"/>
-                </a:solidFill>
-              </a:defRPr>
-            </a:pPr>
-            <a:r>
-              <a:t>•  Direct Attribution: Every alert cites the official university portal with original PDF.</a:t>
-            </a:r>
-          </a:p>
-          <a:p>
-            <a:pPr>
-              <a:spcAft>
-                <a:spcPts val="1000"/>
-              </a:spcAft>
-              <a:defRPr sz="1300">
+                <a:spcPts val="900"/>
+              </a:spcAft>
+              <a:defRPr sz="1250">
+                <a:solidFill>
+                  <a:srgbClr val="0F172A"/>
+                </a:solidFill>
+              </a:defRPr>
+            </a:pPr>
+            <a:r>
+              <a:t>•  Direct Attribution: Every alert cites official university portal with original PDF.</a:t>
+            </a:r>
+          </a:p>
+          <a:p>
+            <a:pPr>
+              <a:spcAft>
+                <a:spcPts val="900"/>
+              </a:spcAft>
+              <a:defRPr sz="1250">
                 <a:solidFill>
                   <a:srgbClr val="0F172A"/>
                 </a:solidFill>
@@ -10494,9 +10494,9 @@
           <a:p>
             <a:pPr>
               <a:spcAft>
-                <a:spcPts val="1000"/>
-              </a:spcAft>
-              <a:defRPr sz="1300">
+                <a:spcPts val="900"/>
+              </a:spcAft>
+              <a:defRPr sz="1250">
                 <a:solidFill>
                   <a:srgbClr val="0F172A"/>
                 </a:solidFill>
@@ -10663,8 +10663,8 @@
         </p:nvSpPr>
         <p:spPr>
           <a:xfrm>
-            <a:off x="7498079" y="164592"/>
-            <a:ext cx="4114800" cy="777240"/>
+            <a:off x="7132320" y="164592"/>
+            <a:ext cx="4480560" cy="777240"/>
           </a:xfrm>
           <a:prstGeom prst="rect">
             <a:avLst/>
@@ -10678,18 +10678,18 @@
           <a:lstStyle/>
           <a:p>
             <a:pPr algn="r">
-              <a:defRPr sz="1100" b="1">
+              <a:defRPr sz="1050" b="1">
                 <a:solidFill>
                   <a:srgbClr val="F97316"/>
                 </a:solidFill>
               </a:defRPr>
             </a:pPr>
             <a:r>
-              <a:t>SMART INDIA HACKATHON 2024</a:t>
+              <a:t>GUJARAT TECHNOLOGICAL UNIVERSITY</a:t>
             </a:r>
             <a:br/>
             <a:r>
-              <a:t>THEME: SMART EDUCATION / AUTOMATION</a:t>
+              <a:t>CAMPUS AUTOMATION &amp; STUDENT WELFARE</a:t>
             </a:r>
           </a:p>
         </p:txBody>
@@ -10703,7 +10703,7 @@
         <p:spPr>
           <a:xfrm>
             <a:off x="594360" y="201168"/>
-            <a:ext cx="6858000" cy="685800"/>
+            <a:ext cx="6583680" cy="685800"/>
           </a:xfrm>
           <a:prstGeom prst="rect">
             <a:avLst/>
@@ -10783,7 +10783,7 @@
         <p:spPr>
           <a:xfrm>
             <a:off x="594360" y="6510528"/>
-            <a:ext cx="7772400" cy="320040"/>
+            <a:ext cx="8046720" cy="320040"/>
           </a:xfrm>
           <a:prstGeom prst="rect">
             <a:avLst/>
@@ -10804,7 +10804,7 @@
               </a:defRPr>
             </a:pPr>
             <a:r>
-              <a:t>SIH 2024  |  Problem: GTU Notice Broadcast Automation  |  Team: GTU Innovators</a:t>
+              <a:t>GTU Circular &amp; Notification Alert System  |  Department of Computer / IT Engineering</a:t>
             </a:r>
           </a:p>
         </p:txBody>
@@ -10898,7 +10898,7 @@
         <p:spPr>
           <a:xfrm>
             <a:off x="594360" y="1234440"/>
-            <a:ext cx="3511296" cy="621792"/>
+            <a:ext cx="3511296" cy="594360"/>
           </a:xfrm>
           <a:prstGeom prst="roundRect">
             <a:avLst/>
@@ -10940,8 +10940,8 @@
         </p:nvSpPr>
         <p:spPr>
           <a:xfrm>
-            <a:off x="777240" y="1289304"/>
-            <a:ext cx="3145536" cy="548640"/>
+            <a:off x="758952" y="1280160"/>
+            <a:ext cx="3182112" cy="521208"/>
           </a:xfrm>
           <a:prstGeom prst="rect">
             <a:avLst/>
@@ -10955,7 +10955,7 @@
           <a:lstStyle/>
           <a:p>
             <a:pPr>
-              <a:defRPr sz="1550" b="1">
+              <a:defRPr sz="1450" b="1">
                 <a:solidFill>
                   <a:srgbClr val="FFFFFF"/>
                 </a:solidFill>
@@ -10967,7 +10967,7 @@
           </a:p>
           <a:p>
             <a:pPr>
-              <a:defRPr sz="1000" b="1">
+              <a:defRPr sz="950" b="1">
                 <a:solidFill>
                   <a:srgbClr val="E0F2FE"/>
                 </a:solidFill>
@@ -10987,8 +10987,8 @@
         </p:nvSpPr>
         <p:spPr>
           <a:xfrm>
-            <a:off x="777240" y="1965960"/>
-            <a:ext cx="3145536" cy="4315968"/>
+            <a:off x="758952" y="1901952"/>
+            <a:ext cx="3182112" cy="4398264"/>
           </a:xfrm>
           <a:prstGeom prst="rect">
             <a:avLst/>
@@ -11003,9 +11003,9 @@
           <a:p>
             <a:pPr>
               <a:spcAft>
-                <a:spcPts val="1100"/>
-              </a:spcAft>
-              <a:defRPr sz="1300">
+                <a:spcPts val="1000"/>
+              </a:spcAft>
+              <a:defRPr sz="1250">
                 <a:solidFill>
                   <a:srgbClr val="0F172A"/>
                 </a:solidFill>
@@ -11018,9 +11018,9 @@
           <a:p>
             <a:pPr>
               <a:spcAft>
-                <a:spcPts val="1100"/>
-              </a:spcAft>
-              <a:defRPr sz="1300">
+                <a:spcPts val="1000"/>
+              </a:spcAft>
+              <a:defRPr sz="1250">
                 <a:solidFill>
                   <a:srgbClr val="0F172A"/>
                 </a:solidFill>
@@ -11033,9 +11033,9 @@
           <a:p>
             <a:pPr>
               <a:spcAft>
-                <a:spcPts val="1100"/>
-              </a:spcAft>
-              <a:defRPr sz="1300">
+                <a:spcPts val="1000"/>
+              </a:spcAft>
+              <a:defRPr sz="1250">
                 <a:solidFill>
                   <a:srgbClr val="0F172A"/>
                 </a:solidFill>
@@ -11048,9 +11048,9 @@
           <a:p>
             <a:pPr>
               <a:spcAft>
-                <a:spcPts val="1100"/>
-              </a:spcAft>
-              <a:defRPr sz="1300">
+                <a:spcPts val="1000"/>
+              </a:spcAft>
+              <a:defRPr sz="1250">
                 <a:solidFill>
                   <a:srgbClr val="0F172A"/>
                 </a:solidFill>
@@ -11063,9 +11063,9 @@
           <a:p>
             <a:pPr>
               <a:spcAft>
-                <a:spcPts val="1100"/>
-              </a:spcAft>
-              <a:defRPr sz="1300">
+                <a:spcPts val="1000"/>
+              </a:spcAft>
+              <a:defRPr sz="1250">
                 <a:solidFill>
                   <a:srgbClr val="0F172A"/>
                 </a:solidFill>
@@ -11078,9 +11078,9 @@
           <a:p>
             <a:pPr>
               <a:spcAft>
-                <a:spcPts val="1100"/>
-              </a:spcAft>
-              <a:defRPr sz="1300">
+                <a:spcPts val="1000"/>
+              </a:spcAft>
+              <a:defRPr sz="1250">
                 <a:solidFill>
                   <a:srgbClr val="0F172A"/>
                 </a:solidFill>
@@ -11146,7 +11146,7 @@
         <p:spPr>
           <a:xfrm>
             <a:off x="4325112" y="1234440"/>
-            <a:ext cx="3511296" cy="621792"/>
+            <a:ext cx="3511296" cy="594360"/>
           </a:xfrm>
           <a:prstGeom prst="roundRect">
             <a:avLst/>
@@ -11188,8 +11188,8 @@
         </p:nvSpPr>
         <p:spPr>
           <a:xfrm>
-            <a:off x="4507992" y="1289304"/>
-            <a:ext cx="3145536" cy="548640"/>
+            <a:off x="4489704" y="1280160"/>
+            <a:ext cx="3182112" cy="521208"/>
           </a:xfrm>
           <a:prstGeom prst="rect">
             <a:avLst/>
@@ -11203,7 +11203,7 @@
           <a:lstStyle/>
           <a:p>
             <a:pPr>
-              <a:defRPr sz="1550" b="1">
+              <a:defRPr sz="1450" b="1">
                 <a:solidFill>
                   <a:srgbClr val="FFFFFF"/>
                 </a:solidFill>
@@ -11215,7 +11215,7 @@
           </a:p>
           <a:p>
             <a:pPr>
-              <a:defRPr sz="1000" b="1">
+              <a:defRPr sz="950" b="1">
                 <a:solidFill>
                   <a:srgbClr val="E0F2FE"/>
                 </a:solidFill>
@@ -11235,8 +11235,8 @@
         </p:nvSpPr>
         <p:spPr>
           <a:xfrm>
-            <a:off x="4507992" y="1965960"/>
-            <a:ext cx="3145536" cy="4315968"/>
+            <a:off x="4489704" y="1901952"/>
+            <a:ext cx="3182112" cy="4398264"/>
           </a:xfrm>
           <a:prstGeom prst="rect">
             <a:avLst/>
@@ -11251,9 +11251,9 @@
           <a:p>
             <a:pPr>
               <a:spcAft>
-                <a:spcPts val="1100"/>
-              </a:spcAft>
-              <a:defRPr sz="1300">
+                <a:spcPts val="1000"/>
+              </a:spcAft>
+              <a:defRPr sz="1250">
                 <a:solidFill>
                   <a:srgbClr val="0F172A"/>
                 </a:solidFill>
@@ -11266,9 +11266,9 @@
           <a:p>
             <a:pPr>
               <a:spcAft>
-                <a:spcPts val="1100"/>
-              </a:spcAft>
-              <a:defRPr sz="1300">
+                <a:spcPts val="1000"/>
+              </a:spcAft>
+              <a:defRPr sz="1250">
                 <a:solidFill>
                   <a:srgbClr val="0F172A"/>
                 </a:solidFill>
@@ -11281,9 +11281,9 @@
           <a:p>
             <a:pPr>
               <a:spcAft>
-                <a:spcPts val="1100"/>
-              </a:spcAft>
-              <a:defRPr sz="1300">
+                <a:spcPts val="1000"/>
+              </a:spcAft>
+              <a:defRPr sz="1250">
                 <a:solidFill>
                   <a:srgbClr val="0F172A"/>
                 </a:solidFill>
@@ -11296,9 +11296,9 @@
           <a:p>
             <a:pPr>
               <a:spcAft>
-                <a:spcPts val="1100"/>
-              </a:spcAft>
-              <a:defRPr sz="1300">
+                <a:spcPts val="1000"/>
+              </a:spcAft>
+              <a:defRPr sz="1250">
                 <a:solidFill>
                   <a:srgbClr val="0F172A"/>
                 </a:solidFill>
@@ -11311,9 +11311,9 @@
           <a:p>
             <a:pPr>
               <a:spcAft>
-                <a:spcPts val="1100"/>
-              </a:spcAft>
-              <a:defRPr sz="1300">
+                <a:spcPts val="1000"/>
+              </a:spcAft>
+              <a:defRPr sz="1250">
                 <a:solidFill>
                   <a:srgbClr val="0F172A"/>
                 </a:solidFill>
@@ -11326,9 +11326,9 @@
           <a:p>
             <a:pPr>
               <a:spcAft>
-                <a:spcPts val="1100"/>
-              </a:spcAft>
-              <a:defRPr sz="1300">
+                <a:spcPts val="1000"/>
+              </a:spcAft>
+              <a:defRPr sz="1250">
                 <a:solidFill>
                   <a:srgbClr val="0F172A"/>
                 </a:solidFill>
@@ -11394,7 +11394,7 @@
         <p:spPr>
           <a:xfrm>
             <a:off x="8055864" y="1234440"/>
-            <a:ext cx="3511296" cy="621792"/>
+            <a:ext cx="3511296" cy="594360"/>
           </a:xfrm>
           <a:prstGeom prst="roundRect">
             <a:avLst/>
@@ -11436,8 +11436,8 @@
         </p:nvSpPr>
         <p:spPr>
           <a:xfrm>
-            <a:off x="8238744" y="1289304"/>
-            <a:ext cx="3145536" cy="548640"/>
+            <a:off x="8220456" y="1280160"/>
+            <a:ext cx="3182112" cy="521208"/>
           </a:xfrm>
           <a:prstGeom prst="rect">
             <a:avLst/>
@@ -11451,7 +11451,7 @@
           <a:lstStyle/>
           <a:p>
             <a:pPr>
-              <a:defRPr sz="1550" b="1">
+              <a:defRPr sz="1450" b="1">
                 <a:solidFill>
                   <a:srgbClr val="FFFFFF"/>
                 </a:solidFill>
@@ -11463,7 +11463,7 @@
           </a:p>
           <a:p>
             <a:pPr>
-              <a:defRPr sz="1000" b="1">
+              <a:defRPr sz="950" b="1">
                 <a:solidFill>
                   <a:srgbClr val="E0F2FE"/>
                 </a:solidFill>
@@ -11483,8 +11483,8 @@
         </p:nvSpPr>
         <p:spPr>
           <a:xfrm>
-            <a:off x="8238744" y="1965960"/>
-            <a:ext cx="3145536" cy="4315968"/>
+            <a:off x="8220456" y="1901952"/>
+            <a:ext cx="3182112" cy="4398264"/>
           </a:xfrm>
           <a:prstGeom prst="rect">
             <a:avLst/>
@@ -11499,9 +11499,9 @@
           <a:p>
             <a:pPr>
               <a:spcAft>
-                <a:spcPts val="1100"/>
-              </a:spcAft>
-              <a:defRPr sz="1300">
+                <a:spcPts val="1000"/>
+              </a:spcAft>
+              <a:defRPr sz="1250">
                 <a:solidFill>
                   <a:srgbClr val="0F172A"/>
                 </a:solidFill>
@@ -11514,9 +11514,9 @@
           <a:p>
             <a:pPr>
               <a:spcAft>
-                <a:spcPts val="1100"/>
-              </a:spcAft>
-              <a:defRPr sz="1300">
+                <a:spcPts val="1000"/>
+              </a:spcAft>
+              <a:defRPr sz="1250">
                 <a:solidFill>
                   <a:srgbClr val="0F172A"/>
                 </a:solidFill>
@@ -11529,9 +11529,9 @@
           <a:p>
             <a:pPr>
               <a:spcAft>
-                <a:spcPts val="1100"/>
-              </a:spcAft>
-              <a:defRPr sz="1300">
+                <a:spcPts val="1000"/>
+              </a:spcAft>
+              <a:defRPr sz="1250">
                 <a:solidFill>
                   <a:srgbClr val="0F172A"/>
                 </a:solidFill>
@@ -11544,9 +11544,9 @@
           <a:p>
             <a:pPr>
               <a:spcAft>
-                <a:spcPts val="1100"/>
-              </a:spcAft>
-              <a:defRPr sz="1300">
+                <a:spcPts val="1000"/>
+              </a:spcAft>
+              <a:defRPr sz="1250">
                 <a:solidFill>
                   <a:srgbClr val="0F172A"/>
                 </a:solidFill>
@@ -11559,9 +11559,9 @@
           <a:p>
             <a:pPr>
               <a:spcAft>
-                <a:spcPts val="1100"/>
-              </a:spcAft>
-              <a:defRPr sz="1300">
+                <a:spcPts val="1000"/>
+              </a:spcAft>
+              <a:defRPr sz="1250">
                 <a:solidFill>
                   <a:srgbClr val="0F172A"/>
                 </a:solidFill>
@@ -11574,9 +11574,9 @@
           <a:p>
             <a:pPr>
               <a:spcAft>
-                <a:spcPts val="1100"/>
-              </a:spcAft>
-              <a:defRPr sz="1300">
+                <a:spcPts val="1000"/>
+              </a:spcAft>
+              <a:defRPr sz="1250">
                 <a:solidFill>
                   <a:srgbClr val="0F172A"/>
                 </a:solidFill>
@@ -11743,8 +11743,8 @@
         </p:nvSpPr>
         <p:spPr>
           <a:xfrm>
-            <a:off x="7498079" y="164592"/>
-            <a:ext cx="4114800" cy="777240"/>
+            <a:off x="7132320" y="164592"/>
+            <a:ext cx="4480560" cy="777240"/>
           </a:xfrm>
           <a:prstGeom prst="rect">
             <a:avLst/>
@@ -11758,18 +11758,18 @@
           <a:lstStyle/>
           <a:p>
             <a:pPr algn="r">
-              <a:defRPr sz="1100" b="1">
+              <a:defRPr sz="1050" b="1">
                 <a:solidFill>
                   <a:srgbClr val="F97316"/>
                 </a:solidFill>
               </a:defRPr>
             </a:pPr>
             <a:r>
-              <a:t>SMART INDIA HACKATHON 2024</a:t>
+              <a:t>GUJARAT TECHNOLOGICAL UNIVERSITY</a:t>
             </a:r>
             <a:br/>
             <a:r>
-              <a:t>THEME: SMART EDUCATION / AUTOMATION</a:t>
+              <a:t>CAMPUS AUTOMATION &amp; STUDENT WELFARE</a:t>
             </a:r>
           </a:p>
         </p:txBody>
@@ -11783,7 +11783,7 @@
         <p:spPr>
           <a:xfrm>
             <a:off x="594360" y="201168"/>
-            <a:ext cx="6858000" cy="685800"/>
+            <a:ext cx="6583680" cy="685800"/>
           </a:xfrm>
           <a:prstGeom prst="rect">
             <a:avLst/>
@@ -11863,7 +11863,7 @@
         <p:spPr>
           <a:xfrm>
             <a:off x="594360" y="6510528"/>
-            <a:ext cx="7772400" cy="320040"/>
+            <a:ext cx="8046720" cy="320040"/>
           </a:xfrm>
           <a:prstGeom prst="rect">
             <a:avLst/>
@@ -11884,7 +11884,7 @@
               </a:defRPr>
             </a:pPr>
             <a:r>
-              <a:t>SIH 2024  |  Problem: GTU Notice Broadcast Automation  |  Team: GTU Innovators</a:t>
+              <a:t>GTU Circular &amp; Notification Alert System  |  Department of Computer / IT Engineering</a:t>
             </a:r>
           </a:p>
         </p:txBody>
@@ -11978,7 +11978,7 @@
         <p:spPr>
           <a:xfrm>
             <a:off x="594360" y="1234440"/>
-            <a:ext cx="3511296" cy="621792"/>
+            <a:ext cx="3511296" cy="594360"/>
           </a:xfrm>
           <a:prstGeom prst="roundRect">
             <a:avLst/>
@@ -12020,8 +12020,8 @@
         </p:nvSpPr>
         <p:spPr>
           <a:xfrm>
-            <a:off x="777240" y="1289304"/>
-            <a:ext cx="3145536" cy="548640"/>
+            <a:off x="758952" y="1280160"/>
+            <a:ext cx="3182112" cy="521208"/>
           </a:xfrm>
           <a:prstGeom prst="rect">
             <a:avLst/>
@@ -12035,7 +12035,7 @@
           <a:lstStyle/>
           <a:p>
             <a:pPr>
-              <a:defRPr sz="1550" b="1">
+              <a:defRPr sz="1450" b="1">
                 <a:solidFill>
                   <a:srgbClr val="FFFFFF"/>
                 </a:solidFill>
@@ -12047,7 +12047,7 @@
           </a:p>
           <a:p>
             <a:pPr>
-              <a:defRPr sz="1000" b="1">
+              <a:defRPr sz="950" b="1">
                 <a:solidFill>
                   <a:srgbClr val="E0F2FE"/>
                 </a:solidFill>
@@ -12067,8 +12067,8 @@
         </p:nvSpPr>
         <p:spPr>
           <a:xfrm>
-            <a:off x="777240" y="1965960"/>
-            <a:ext cx="3145536" cy="4315968"/>
+            <a:off x="758952" y="1901952"/>
+            <a:ext cx="3182112" cy="4398264"/>
           </a:xfrm>
           <a:prstGeom prst="rect">
             <a:avLst/>
@@ -12083,9 +12083,9 @@
           <a:p>
             <a:pPr>
               <a:spcAft>
-                <a:spcPts val="1100"/>
-              </a:spcAft>
-              <a:defRPr sz="1300">
+                <a:spcPts val="1000"/>
+              </a:spcAft>
+              <a:defRPr sz="1250">
                 <a:solidFill>
                   <a:srgbClr val="0F172A"/>
                 </a:solidFill>
@@ -12098,9 +12098,9 @@
           <a:p>
             <a:pPr>
               <a:spcAft>
-                <a:spcPts val="1100"/>
-              </a:spcAft>
-              <a:defRPr sz="1300">
+                <a:spcPts val="1000"/>
+              </a:spcAft>
+              <a:defRPr sz="1250">
                 <a:solidFill>
                   <a:srgbClr val="0F172A"/>
                 </a:solidFill>
@@ -12113,9 +12113,9 @@
           <a:p>
             <a:pPr>
               <a:spcAft>
-                <a:spcPts val="1100"/>
-              </a:spcAft>
-              <a:defRPr sz="1300">
+                <a:spcPts val="1000"/>
+              </a:spcAft>
+              <a:defRPr sz="1250">
                 <a:solidFill>
                   <a:srgbClr val="0F172A"/>
                 </a:solidFill>
@@ -12128,9 +12128,9 @@
           <a:p>
             <a:pPr>
               <a:spcAft>
-                <a:spcPts val="1100"/>
-              </a:spcAft>
-              <a:defRPr sz="1300">
+                <a:spcPts val="1000"/>
+              </a:spcAft>
+              <a:defRPr sz="1250">
                 <a:solidFill>
                   <a:srgbClr val="0F172A"/>
                 </a:solidFill>
@@ -12143,9 +12143,9 @@
           <a:p>
             <a:pPr>
               <a:spcAft>
-                <a:spcPts val="1100"/>
-              </a:spcAft>
-              <a:defRPr sz="1300">
+                <a:spcPts val="1000"/>
+              </a:spcAft>
+              <a:defRPr sz="1250">
                 <a:solidFill>
                   <a:srgbClr val="0F172A"/>
                 </a:solidFill>
@@ -12211,7 +12211,7 @@
         <p:spPr>
           <a:xfrm>
             <a:off x="4325112" y="1234440"/>
-            <a:ext cx="3511296" cy="621792"/>
+            <a:ext cx="3511296" cy="594360"/>
           </a:xfrm>
           <a:prstGeom prst="roundRect">
             <a:avLst/>
@@ -12253,8 +12253,8 @@
         </p:nvSpPr>
         <p:spPr>
           <a:xfrm>
-            <a:off x="4507992" y="1289304"/>
-            <a:ext cx="3145536" cy="548640"/>
+            <a:off x="4489704" y="1280160"/>
+            <a:ext cx="3182112" cy="521208"/>
           </a:xfrm>
           <a:prstGeom prst="rect">
             <a:avLst/>
@@ -12268,7 +12268,7 @@
           <a:lstStyle/>
           <a:p>
             <a:pPr>
-              <a:defRPr sz="1550" b="1">
+              <a:defRPr sz="1450" b="1">
                 <a:solidFill>
                   <a:srgbClr val="FFFFFF"/>
                 </a:solidFill>
@@ -12280,7 +12280,7 @@
           </a:p>
           <a:p>
             <a:pPr>
-              <a:defRPr sz="1000" b="1">
+              <a:defRPr sz="950" b="1">
                 <a:solidFill>
                   <a:srgbClr val="E0F2FE"/>
                 </a:solidFill>
@@ -12300,8 +12300,8 @@
         </p:nvSpPr>
         <p:spPr>
           <a:xfrm>
-            <a:off x="4507992" y="1965960"/>
-            <a:ext cx="3145536" cy="4315968"/>
+            <a:off x="4489704" y="1901952"/>
+            <a:ext cx="3182112" cy="4398264"/>
           </a:xfrm>
           <a:prstGeom prst="rect">
             <a:avLst/>
@@ -12316,9 +12316,9 @@
           <a:p>
             <a:pPr>
               <a:spcAft>
-                <a:spcPts val="1100"/>
-              </a:spcAft>
-              <a:defRPr sz="1300">
+                <a:spcPts val="1000"/>
+              </a:spcAft>
+              <a:defRPr sz="1250">
                 <a:solidFill>
                   <a:srgbClr val="0F172A"/>
                 </a:solidFill>
@@ -12331,9 +12331,9 @@
           <a:p>
             <a:pPr>
               <a:spcAft>
-                <a:spcPts val="1100"/>
-              </a:spcAft>
-              <a:defRPr sz="1300">
+                <a:spcPts val="1000"/>
+              </a:spcAft>
+              <a:defRPr sz="1250">
                 <a:solidFill>
                   <a:srgbClr val="0F172A"/>
                 </a:solidFill>
@@ -12346,9 +12346,9 @@
           <a:p>
             <a:pPr>
               <a:spcAft>
-                <a:spcPts val="1100"/>
-              </a:spcAft>
-              <a:defRPr sz="1300">
+                <a:spcPts val="1000"/>
+              </a:spcAft>
+              <a:defRPr sz="1250">
                 <a:solidFill>
                   <a:srgbClr val="0F172A"/>
                 </a:solidFill>
@@ -12361,9 +12361,9 @@
           <a:p>
             <a:pPr>
               <a:spcAft>
-                <a:spcPts val="1100"/>
-              </a:spcAft>
-              <a:defRPr sz="1300">
+                <a:spcPts val="1000"/>
+              </a:spcAft>
+              <a:defRPr sz="1250">
                 <a:solidFill>
                   <a:srgbClr val="0F172A"/>
                 </a:solidFill>
@@ -12376,9 +12376,9 @@
           <a:p>
             <a:pPr>
               <a:spcAft>
-                <a:spcPts val="1100"/>
-              </a:spcAft>
-              <a:defRPr sz="1300">
+                <a:spcPts val="1000"/>
+              </a:spcAft>
+              <a:defRPr sz="1250">
                 <a:solidFill>
                   <a:srgbClr val="0F172A"/>
                 </a:solidFill>
@@ -12444,7 +12444,7 @@
         <p:spPr>
           <a:xfrm>
             <a:off x="8055864" y="1234440"/>
-            <a:ext cx="3511296" cy="621792"/>
+            <a:ext cx="3511296" cy="594360"/>
           </a:xfrm>
           <a:prstGeom prst="roundRect">
             <a:avLst/>
@@ -12486,8 +12486,8 @@
         </p:nvSpPr>
         <p:spPr>
           <a:xfrm>
-            <a:off x="8238744" y="1289304"/>
-            <a:ext cx="3145536" cy="548640"/>
+            <a:off x="8220456" y="1280160"/>
+            <a:ext cx="3182112" cy="521208"/>
           </a:xfrm>
           <a:prstGeom prst="rect">
             <a:avLst/>
@@ -12501,26 +12501,26 @@
           <a:lstStyle/>
           <a:p>
             <a:pPr>
-              <a:defRPr sz="1550" b="1">
+              <a:defRPr sz="1450" b="1">
                 <a:solidFill>
                   <a:srgbClr val="FFFFFF"/>
                 </a:solidFill>
               </a:defRPr>
             </a:pPr>
             <a:r>
-              <a:t>National Mission Alignment</a:t>
-            </a:r>
-          </a:p>
-          <a:p>
-            <a:pPr>
-              <a:defRPr sz="1000" b="1">
+              <a:t>Digital Campus Alignment</a:t>
+            </a:r>
+          </a:p>
+          <a:p>
+            <a:pPr>
+              <a:defRPr sz="950" b="1">
                 <a:solidFill>
                   <a:srgbClr val="E0F2FE"/>
                 </a:solidFill>
               </a:defRPr>
             </a:pPr>
             <a:r>
-              <a:t>NATIONAL IMPACT</a:t>
+              <a:t>CAMPUS INNOVATION</a:t>
             </a:r>
           </a:p>
         </p:txBody>
@@ -12533,8 +12533,8 @@
         </p:nvSpPr>
         <p:spPr>
           <a:xfrm>
-            <a:off x="8238744" y="1965960"/>
-            <a:ext cx="3145536" cy="4315968"/>
+            <a:off x="8220456" y="1901952"/>
+            <a:ext cx="3182112" cy="4398264"/>
           </a:xfrm>
           <a:prstGeom prst="rect">
             <a:avLst/>
@@ -12549,9 +12549,9 @@
           <a:p>
             <a:pPr>
               <a:spcAft>
-                <a:spcPts val="1100"/>
-              </a:spcAft>
-              <a:defRPr sz="1300">
+                <a:spcPts val="1000"/>
+              </a:spcAft>
+              <a:defRPr sz="1250">
                 <a:solidFill>
                   <a:srgbClr val="0F172A"/>
                 </a:solidFill>
@@ -12564,9 +12564,9 @@
           <a:p>
             <a:pPr>
               <a:spcAft>
-                <a:spcPts val="1100"/>
-              </a:spcAft>
-              <a:defRPr sz="1300">
+                <a:spcPts val="1000"/>
+              </a:spcAft>
+              <a:defRPr sz="1250">
                 <a:solidFill>
                   <a:srgbClr val="0F172A"/>
                 </a:solidFill>
@@ -12579,39 +12579,39 @@
           <a:p>
             <a:pPr>
               <a:spcAft>
-                <a:spcPts val="1100"/>
-              </a:spcAft>
-              <a:defRPr sz="1300">
-                <a:solidFill>
-                  <a:srgbClr val="0F172A"/>
-                </a:solidFill>
-              </a:defRPr>
-            </a:pPr>
-            <a:r>
-              <a:t>•  Accessible India Campaign (Sugamya Bharat): Voice bulletins for disabled students.</a:t>
-            </a:r>
-          </a:p>
-          <a:p>
-            <a:pPr>
-              <a:spcAft>
-                <a:spcPts val="1100"/>
-              </a:spcAft>
-              <a:defRPr sz="1300">
-                <a:solidFill>
-                  <a:srgbClr val="0F172A"/>
-                </a:solidFill>
-              </a:defRPr>
-            </a:pPr>
-            <a:r>
-              <a:t>•  Atmanirbhar Bharat: 100% student-developed open-source university solution.</a:t>
-            </a:r>
-          </a:p>
-          <a:p>
-            <a:pPr>
-              <a:spcAft>
-                <a:spcPts val="1100"/>
-              </a:spcAft>
-              <a:defRPr sz="1300">
+                <a:spcPts val="1000"/>
+              </a:spcAft>
+              <a:defRPr sz="1250">
+                <a:solidFill>
+                  <a:srgbClr val="0F172A"/>
+                </a:solidFill>
+              </a:defRPr>
+            </a:pPr>
+            <a:r>
+              <a:t>•  Accessible Education: Voice bulletins for visually challenged students.</a:t>
+            </a:r>
+          </a:p>
+          <a:p>
+            <a:pPr>
+              <a:spcAft>
+                <a:spcPts val="1000"/>
+              </a:spcAft>
+              <a:defRPr sz="1250">
+                <a:solidFill>
+                  <a:srgbClr val="0F172A"/>
+                </a:solidFill>
+              </a:defRPr>
+            </a:pPr>
+            <a:r>
+              <a:t>•  Atmanirbhar Campus: 100% student-developed open-source university solution.</a:t>
+            </a:r>
+          </a:p>
+          <a:p>
+            <a:pPr>
+              <a:spcAft>
+                <a:spcPts val="1000"/>
+              </a:spcAft>
+              <a:defRPr sz="1250">
                 <a:solidFill>
                   <a:srgbClr val="0F172A"/>
                 </a:solidFill>
@@ -12778,8 +12778,8 @@
         </p:nvSpPr>
         <p:spPr>
           <a:xfrm>
-            <a:off x="7498079" y="164592"/>
-            <a:ext cx="4114800" cy="777240"/>
+            <a:off x="7132320" y="164592"/>
+            <a:ext cx="4480560" cy="777240"/>
           </a:xfrm>
           <a:prstGeom prst="rect">
             <a:avLst/>
@@ -12793,18 +12793,18 @@
           <a:lstStyle/>
           <a:p>
             <a:pPr algn="r">
-              <a:defRPr sz="1100" b="1">
+              <a:defRPr sz="1050" b="1">
                 <a:solidFill>
                   <a:srgbClr val="F97316"/>
                 </a:solidFill>
               </a:defRPr>
             </a:pPr>
             <a:r>
-              <a:t>SMART INDIA HACKATHON 2024</a:t>
+              <a:t>GUJARAT TECHNOLOGICAL UNIVERSITY</a:t>
             </a:r>
             <a:br/>
             <a:r>
-              <a:t>THEME: SMART EDUCATION / AUTOMATION</a:t>
+              <a:t>CAMPUS AUTOMATION &amp; STUDENT WELFARE</a:t>
             </a:r>
           </a:p>
         </p:txBody>
@@ -12818,7 +12818,7 @@
         <p:spPr>
           <a:xfrm>
             <a:off x="594360" y="201168"/>
-            <a:ext cx="6858000" cy="685800"/>
+            <a:ext cx="6583680" cy="685800"/>
           </a:xfrm>
           <a:prstGeom prst="rect">
             <a:avLst/>
@@ -12898,7 +12898,7 @@
         <p:spPr>
           <a:xfrm>
             <a:off x="594360" y="6510528"/>
-            <a:ext cx="7772400" cy="320040"/>
+            <a:ext cx="8046720" cy="320040"/>
           </a:xfrm>
           <a:prstGeom prst="rect">
             <a:avLst/>
@@ -12919,7 +12919,7 @@
               </a:defRPr>
             </a:pPr>
             <a:r>
-              <a:t>SIH 2024  |  Problem: GTU Notice Broadcast Automation  |  Team: GTU Innovators</a:t>
+              <a:t>GTU Circular &amp; Notification Alert System  |  Department of Computer / IT Engineering</a:t>
             </a:r>
           </a:p>
         </p:txBody>
@@ -13013,7 +13013,7 @@
         <p:spPr>
           <a:xfrm>
             <a:off x="594360" y="1234440"/>
-            <a:ext cx="5376672" cy="621792"/>
+            <a:ext cx="5376672" cy="594360"/>
           </a:xfrm>
           <a:prstGeom prst="roundRect">
             <a:avLst/>
@@ -13055,8 +13055,8 @@
         </p:nvSpPr>
         <p:spPr>
           <a:xfrm>
-            <a:off x="777240" y="1289304"/>
-            <a:ext cx="5010912" cy="548640"/>
+            <a:off x="758952" y="1280160"/>
+            <a:ext cx="5047488" cy="521208"/>
           </a:xfrm>
           <a:prstGeom prst="rect">
             <a:avLst/>
@@ -13070,7 +13070,7 @@
           <a:lstStyle/>
           <a:p>
             <a:pPr>
-              <a:defRPr sz="1550" b="1">
+              <a:defRPr sz="1450" b="1">
                 <a:solidFill>
                   <a:srgbClr val="FFFFFF"/>
                 </a:solidFill>
@@ -13082,7 +13082,7 @@
           </a:p>
           <a:p>
             <a:pPr>
-              <a:defRPr sz="1000" b="1">
+              <a:defRPr sz="950" b="1">
                 <a:solidFill>
                   <a:srgbClr val="E0F2FE"/>
                 </a:solidFill>
@@ -13102,8 +13102,8 @@
         </p:nvSpPr>
         <p:spPr>
           <a:xfrm>
-            <a:off x="777240" y="1965960"/>
-            <a:ext cx="5010912" cy="4315968"/>
+            <a:off x="758952" y="1901952"/>
+            <a:ext cx="5047488" cy="4398264"/>
           </a:xfrm>
           <a:prstGeom prst="rect">
             <a:avLst/>
@@ -13118,9 +13118,9 @@
           <a:p>
             <a:pPr>
               <a:spcAft>
-                <a:spcPts val="1100"/>
-              </a:spcAft>
-              <a:defRPr sz="1300">
+                <a:spcPts val="1000"/>
+              </a:spcAft>
+              <a:defRPr sz="1250">
                 <a:solidFill>
                   <a:srgbClr val="0F172A"/>
                 </a:solidFill>
@@ -13133,9 +13133,9 @@
           <a:p>
             <a:pPr>
               <a:spcAft>
-                <a:spcPts val="1100"/>
-              </a:spcAft>
-              <a:defRPr sz="1300">
+                <a:spcPts val="1000"/>
+              </a:spcAft>
+              <a:defRPr sz="1250">
                 <a:solidFill>
                   <a:srgbClr val="0F172A"/>
                 </a:solidFill>
@@ -13148,9 +13148,9 @@
           <a:p>
             <a:pPr>
               <a:spcAft>
-                <a:spcPts val="1100"/>
-              </a:spcAft>
-              <a:defRPr sz="1300">
+                <a:spcPts val="1000"/>
+              </a:spcAft>
+              <a:defRPr sz="1250">
                 <a:solidFill>
                   <a:srgbClr val="0F172A"/>
                 </a:solidFill>
@@ -13163,9 +13163,9 @@
           <a:p>
             <a:pPr>
               <a:spcAft>
-                <a:spcPts val="1100"/>
-              </a:spcAft>
-              <a:defRPr sz="1300">
+                <a:spcPts val="1000"/>
+              </a:spcAft>
+              <a:defRPr sz="1250">
                 <a:solidFill>
                   <a:srgbClr val="0F172A"/>
                 </a:solidFill>
@@ -13178,9 +13178,9 @@
           <a:p>
             <a:pPr>
               <a:spcAft>
-                <a:spcPts val="1100"/>
-              </a:spcAft>
-              <a:defRPr sz="1300">
+                <a:spcPts val="1000"/>
+              </a:spcAft>
+              <a:defRPr sz="1250">
                 <a:solidFill>
                   <a:srgbClr val="0F172A"/>
                 </a:solidFill>
@@ -13193,9 +13193,9 @@
           <a:p>
             <a:pPr>
               <a:spcAft>
-                <a:spcPts val="1100"/>
-              </a:spcAft>
-              <a:defRPr sz="1300">
+                <a:spcPts val="1000"/>
+              </a:spcAft>
+              <a:defRPr sz="1250">
                 <a:solidFill>
                   <a:srgbClr val="0F172A"/>
                 </a:solidFill>
@@ -13208,9 +13208,9 @@
           <a:p>
             <a:pPr>
               <a:spcAft>
-                <a:spcPts val="1100"/>
-              </a:spcAft>
-              <a:defRPr sz="1300">
+                <a:spcPts val="1000"/>
+              </a:spcAft>
+              <a:defRPr sz="1250">
                 <a:solidFill>
                   <a:srgbClr val="0F172A"/>
                 </a:solidFill>
@@ -13276,7 +13276,7 @@
         <p:spPr>
           <a:xfrm>
             <a:off x="6190488" y="1234440"/>
-            <a:ext cx="5376672" cy="621792"/>
+            <a:ext cx="5376672" cy="594360"/>
           </a:xfrm>
           <a:prstGeom prst="roundRect">
             <a:avLst/>
@@ -13318,8 +13318,8 @@
         </p:nvSpPr>
         <p:spPr>
           <a:xfrm>
-            <a:off x="6373368" y="1289304"/>
-            <a:ext cx="5010912" cy="548640"/>
+            <a:off x="6355080" y="1280160"/>
+            <a:ext cx="5047488" cy="521208"/>
           </a:xfrm>
           <a:prstGeom prst="rect">
             <a:avLst/>
@@ -13333,7 +13333,7 @@
           <a:lstStyle/>
           <a:p>
             <a:pPr>
-              <a:defRPr sz="1550" b="1">
+              <a:defRPr sz="1450" b="1">
                 <a:solidFill>
                   <a:srgbClr val="FFFFFF"/>
                 </a:solidFill>
@@ -13345,7 +13345,7 @@
           </a:p>
           <a:p>
             <a:pPr>
-              <a:defRPr sz="1000" b="1">
+              <a:defRPr sz="950" b="1">
                 <a:solidFill>
                   <a:srgbClr val="E0F2FE"/>
                 </a:solidFill>
@@ -13365,8 +13365,8 @@
         </p:nvSpPr>
         <p:spPr>
           <a:xfrm>
-            <a:off x="6373368" y="1965960"/>
-            <a:ext cx="5010912" cy="4315968"/>
+            <a:off x="6355080" y="1901952"/>
+            <a:ext cx="5047488" cy="4398264"/>
           </a:xfrm>
           <a:prstGeom prst="rect">
             <a:avLst/>
@@ -13381,9 +13381,9 @@
           <a:p>
             <a:pPr>
               <a:spcAft>
-                <a:spcPts val="1100"/>
-              </a:spcAft>
-              <a:defRPr sz="1300">
+                <a:spcPts val="1000"/>
+              </a:spcAft>
+              <a:defRPr sz="1250">
                 <a:solidFill>
                   <a:srgbClr val="0F172A"/>
                 </a:solidFill>
@@ -13396,9 +13396,9 @@
           <a:p>
             <a:pPr>
               <a:spcAft>
-                <a:spcPts val="1100"/>
-              </a:spcAft>
-              <a:defRPr sz="1300">
+                <a:spcPts val="1000"/>
+              </a:spcAft>
+              <a:defRPr sz="1250">
                 <a:solidFill>
                   <a:srgbClr val="0F172A"/>
                 </a:solidFill>
@@ -13411,9 +13411,9 @@
           <a:p>
             <a:pPr>
               <a:spcAft>
-                <a:spcPts val="1100"/>
-              </a:spcAft>
-              <a:defRPr sz="1300">
+                <a:spcPts val="1000"/>
+              </a:spcAft>
+              <a:defRPr sz="1250">
                 <a:solidFill>
                   <a:srgbClr val="0F172A"/>
                 </a:solidFill>
@@ -13426,9 +13426,9 @@
           <a:p>
             <a:pPr>
               <a:spcAft>
-                <a:spcPts val="1100"/>
-              </a:spcAft>
-              <a:defRPr sz="1300">
+                <a:spcPts val="1000"/>
+              </a:spcAft>
+              <a:defRPr sz="1250">
                 <a:solidFill>
                   <a:srgbClr val="0F172A"/>
                 </a:solidFill>
@@ -13441,9 +13441,9 @@
           <a:p>
             <a:pPr>
               <a:spcAft>
-                <a:spcPts val="1100"/>
-              </a:spcAft>
-              <a:defRPr sz="1300">
+                <a:spcPts val="1000"/>
+              </a:spcAft>
+              <a:defRPr sz="1250">
                 <a:solidFill>
                   <a:srgbClr val="0F172A"/>
                 </a:solidFill>
@@ -13456,9 +13456,9 @@
           <a:p>
             <a:pPr>
               <a:spcAft>
-                <a:spcPts val="1100"/>
-              </a:spcAft>
-              <a:defRPr sz="1300">
+                <a:spcPts val="1000"/>
+              </a:spcAft>
+              <a:defRPr sz="1250">
                 <a:solidFill>
                   <a:srgbClr val="0F172A"/>
                 </a:solidFill>
@@ -13471,9 +13471,9 @@
           <a:p>
             <a:pPr>
               <a:spcAft>
-                <a:spcPts val="1100"/>
-              </a:spcAft>
-              <a:defRPr sz="1300">
+                <a:spcPts val="1000"/>
+              </a:spcAft>
+              <a:defRPr sz="1250">
                 <a:solidFill>
                   <a:srgbClr val="0F172A"/>
                 </a:solidFill>

</xml_diff>

<commit_message>
feat: add Ask GTU AI assistant and update presentation deck
</commit_message>
<xml_diff>
--- a/SIH2024_GTU_Alert_System_Presentation.pptx
+++ b/SIH2024_GTU_Alert_System_Presentation.pptx
@@ -7027,7 +7027,7 @@
               </a:defRPr>
             </a:pPr>
             <a:r>
-              <a:t>3. AI Summarizer &amp; Gujarati Localization</a:t>
+              <a:t>3. 'Ask GTU AI' &amp; Multilingual Intelligence</a:t>
             </a:r>
           </a:p>
         </p:txBody>
@@ -7065,7 +7065,7 @@
               </a:defRPr>
             </a:pPr>
             <a:r>
-              <a:t>•  Google Gemini AI summarizes complex notices into 2 clear sentences.</a:t>
+              <a:t>•  Google Gemini AI + Semantic Q&amp;A for natural language queries.</a:t>
             </a:r>
           </a:p>
           <a:p>
@@ -7080,7 +7080,7 @@
               </a:defRPr>
             </a:pPr>
             <a:r>
-              <a:t>•  Smart offline heuristic fallback ensures 100% zero downtime.</a:t>
+              <a:t>•  Ask GTU AI: Answers 'When is ME deadline?' or 'Pharmacy recheck'.</a:t>
             </a:r>
           </a:p>
           <a:p>
@@ -7110,7 +7110,7 @@
               </a:defRPr>
             </a:pPr>
             <a:r>
-              <a:t>•  Instantly highlights who needs to act, deadline date, and fee amount.</a:t>
+              <a:t>•  Instantly highlights action required, deadline date, and fee amount.</a:t>
             </a:r>
           </a:p>
         </p:txBody>
@@ -7233,7 +7233,7 @@
               </a:defRPr>
             </a:pPr>
             <a:r>
-              <a:t>4. Multi-Channel Accessibility &amp; Voice News</a:t>
+              <a:t>4. Multi-Channel Accessibility &amp; Live Web Dashboard</a:t>
             </a:r>
           </a:p>
         </p:txBody>
@@ -7271,7 +7271,7 @@
               </a:defRPr>
             </a:pPr>
             <a:r>
-              <a:t>•  Daily Voice Bulletin (30-sec MP3 audio briefing) for busy commuters.</a:t>
+              <a:t>•  Ask GTU AI Assistant with one-click suggestion chips on Web.</a:t>
             </a:r>
           </a:p>
           <a:p>
@@ -7286,6 +7286,21 @@
               </a:defRPr>
             </a:pPr>
             <a:r>
+              <a:t>•  Daily Voice Bulletin (30-sec MP3 audio briefing) for commuters.</a:t>
+            </a:r>
+          </a:p>
+          <a:p>
+            <a:pPr>
+              <a:spcAft>
+                <a:spcPts val="600"/>
+              </a:spcAft>
+              <a:defRPr sz="1200">
+                <a:solidFill>
+                  <a:srgbClr val="0F172A"/>
+                </a:solidFill>
+              </a:defRPr>
+            </a:pPr>
+            <a:r>
               <a:t>•  Modern PWA Web Dashboard with Live Search &amp; Stream Filters.</a:t>
             </a:r>
           </a:p>
@@ -7301,22 +7316,7 @@
               </a:defRPr>
             </a:pPr>
             <a:r>
-              <a:t>•  Offline Service Worker cache allows viewing without internet.</a:t>
-            </a:r>
-          </a:p>
-          <a:p>
-            <a:pPr>
-              <a:spcAft>
-                <a:spcPts val="600"/>
-              </a:spcAft>
-              <a:defRPr sz="1200">
-                <a:solidFill>
-                  <a:srgbClr val="0F172A"/>
-                </a:solidFill>
-              </a:defRPr>
-            </a:pPr>
-            <a:r>
-              <a:t>•  Zero-Cost Cloud Deployment via GitHub Pages &amp; GitHub Actions.</a:t>
+              <a:t>•  Zero-Cost 24/7 Cloud Deployment via GitHub Pages &amp; GitHub Actions.</a:t>
             </a:r>
           </a:p>
         </p:txBody>
@@ -8381,6 +8381,21 @@
               </a:defRPr>
             </a:pPr>
             <a:r>
+              <a:t>•  Ask GTU AI: Semantic search &amp; Q&amp;A engine</a:t>
+            </a:r>
+          </a:p>
+          <a:p>
+            <a:pPr>
+              <a:spcAft>
+                <a:spcPts val="1000"/>
+              </a:spcAft>
+              <a:defRPr sz="1200">
+                <a:solidFill>
+                  <a:srgbClr val="0F172A"/>
+                </a:solidFill>
+              </a:defRPr>
+            </a:pPr>
+            <a:r>
               <a:t>•  ai_summarizer.py: Gemini AI 1-line takeaways</a:t>
             </a:r>
           </a:p>
@@ -8427,21 +8442,6 @@
             </a:pPr>
             <a:r>
               <a:t>•  calendar_sync.py: .ics event creator</a:t>
-            </a:r>
-          </a:p>
-          <a:p>
-            <a:pPr>
-              <a:spcAft>
-                <a:spcPts val="1000"/>
-              </a:spcAft>
-              <a:defRPr sz="1200">
-                <a:solidFill>
-                  <a:srgbClr val="0F172A"/>
-                </a:solidFill>
-              </a:defRPr>
-            </a:pPr>
-            <a:r>
-              <a:t>•  pdf_inspector.py: Safe cached text stream</a:t>
             </a:r>
           </a:p>
         </p:txBody>
@@ -8629,7 +8629,7 @@
               </a:defRPr>
             </a:pPr>
             <a:r>
-              <a:t>•  Interactive 2-Way Bot (/latest, /search)</a:t>
+              <a:t>•  Interactive Bot (/ask, /latest, /search)</a:t>
             </a:r>
           </a:p>
           <a:p>
@@ -8644,6 +8644,21 @@
               </a:defRPr>
             </a:pPr>
             <a:r>
+              <a:t>•  Web AI Assistant (Client Semantic Q&amp;A)</a:t>
+            </a:r>
+          </a:p>
+          <a:p>
+            <a:pPr>
+              <a:spcAft>
+                <a:spcPts val="1000"/>
+              </a:spcAft>
+              <a:defRPr sz="1200">
+                <a:solidFill>
+                  <a:srgbClr val="0F172A"/>
+                </a:solidFill>
+              </a:defRPr>
+            </a:pPr>
+            <a:r>
               <a:t>•  Discord Webhook: Rich color embeds</a:t>
             </a:r>
           </a:p>
@@ -8660,21 +8675,6 @@
             </a:pPr>
             <a:r>
               <a:t>•  PWA Web Dashboard (web/index.html)</a:t>
-            </a:r>
-          </a:p>
-          <a:p>
-            <a:pPr>
-              <a:spcAft>
-                <a:spcPts val="1000"/>
-              </a:spcAft>
-              <a:defRPr sz="1200">
-                <a:solidFill>
-                  <a:srgbClr val="0F172A"/>
-                </a:solidFill>
-              </a:defRPr>
-            </a:pPr>
-            <a:r>
-              <a:t>•  Native voice notes delivery</a:t>
             </a:r>
           </a:p>
           <a:p>
@@ -9258,7 +9258,7 @@
               </a:defRPr>
             </a:pPr>
             <a:r>
-              <a:t>•  AI &amp; NLP: Google Gemini 1.5 Flash API + Regex Heuristic Engine</a:t>
+              <a:t>•  AI &amp; NLP: Google Gemini 1.5 Flash + Client-Side Semantic Q&amp;A</a:t>
             </a:r>
           </a:p>
           <a:p>
@@ -9318,7 +9318,7 @@
               </a:defRPr>
             </a:pPr>
             <a:r>
-              <a:t>•  CI/CD Automation: GitHub Actions (Scheduled Ubuntu Runner)</a:t>
+              <a:t>•  CI/CD Automation: GitHub Actions (Scheduled 15-Min Cloud Runner)</a:t>
             </a:r>
           </a:p>
           <a:p>
@@ -9333,7 +9333,7 @@
               </a:defRPr>
             </a:pPr>
             <a:r>
-              <a:t>•  Hosting: GitHub Pages (Static Serverless JSON Architecture)</a:t>
+              <a:t>•  Hosting: GitHub Pages (24/7 Zero-Cost Serverless Cloud)</a:t>
             </a:r>
           </a:p>
           <a:p>
@@ -9512,7 +9512,7 @@
           <a:p>
             <a:pPr>
               <a:spcAft>
-                <a:spcPts val="800"/>
+                <a:spcPts val="700"/>
               </a:spcAft>
               <a:defRPr sz="1250">
                 <a:solidFill>
@@ -9527,7 +9527,7 @@
           <a:p>
             <a:pPr>
               <a:spcAft>
-                <a:spcPts val="800"/>
+                <a:spcPts val="700"/>
               </a:spcAft>
               <a:defRPr sz="1250">
                 <a:solidFill>
@@ -9542,7 +9542,7 @@
           <a:p>
             <a:pPr>
               <a:spcAft>
-                <a:spcPts val="800"/>
+                <a:spcPts val="700"/>
               </a:spcAft>
               <a:defRPr sz="1250">
                 <a:solidFill>
@@ -9557,7 +9557,7 @@
           <a:p>
             <a:pPr>
               <a:spcAft>
-                <a:spcPts val="800"/>
+                <a:spcPts val="700"/>
               </a:spcAft>
               <a:defRPr sz="1250">
                 <a:solidFill>
@@ -9566,13 +9566,13 @@
               </a:defRPr>
             </a:pPr>
             <a:r>
-              <a:t>•  Unique Feature 1: Spoken Daily Voice Bulletin (audio news for accessibility).</a:t>
-            </a:r>
-          </a:p>
-          <a:p>
-            <a:pPr>
-              <a:spcAft>
-                <a:spcPts val="800"/>
+              <a:t>•  Unique Feature 1: 'Ask GTU AI' natural language Q&amp;A (Web &amp; Telegram).</a:t>
+            </a:r>
+          </a:p>
+          <a:p>
+            <a:pPr>
+              <a:spcAft>
+                <a:spcPts val="700"/>
               </a:spcAft>
               <a:defRPr sz="1250">
                 <a:solidFill>
@@ -9581,13 +9581,13 @@
               </a:defRPr>
             </a:pPr>
             <a:r>
-              <a:t>•  Unique Feature 2: Automated Penalty &amp; Deadline Extractor with Calendar Sync (.ics).</a:t>
-            </a:r>
-          </a:p>
-          <a:p>
-            <a:pPr>
-              <a:spcAft>
-                <a:spcPts val="800"/>
+              <a:t>•  Unique Feature 2: 24/7 Cloud Autonomous Operation (Zero PC dependency).</a:t>
+            </a:r>
+          </a:p>
+          <a:p>
+            <a:pPr>
+              <a:spcAft>
+                <a:spcPts val="700"/>
               </a:spcAft>
               <a:defRPr sz="1250">
                 <a:solidFill>
@@ -9596,13 +9596,13 @@
               </a:defRPr>
             </a:pPr>
             <a:r>
-              <a:t>•  Unique Feature 3: Serverless Zero-Cost Operation (Runs forever on GitHub free tier).</a:t>
-            </a:r>
-          </a:p>
-          <a:p>
-            <a:pPr>
-              <a:spcAft>
-                <a:spcPts val="800"/>
+              <a:t>•  Unique Feature 3: Spoken Daily Voice Bulletin (audio news for accessibility).</a:t>
+            </a:r>
+          </a:p>
+          <a:p>
+            <a:pPr>
+              <a:spcAft>
+                <a:spcPts val="700"/>
               </a:spcAft>
               <a:defRPr sz="1250">
                 <a:solidFill>
@@ -9611,13 +9611,13 @@
               </a:defRPr>
             </a:pPr>
             <a:r>
-              <a:t>•  Unique Feature 4: 100% Strict Student Privacy (Zero credentials or personal data stored).</a:t>
-            </a:r>
-          </a:p>
-          <a:p>
-            <a:pPr>
-              <a:spcAft>
-                <a:spcPts val="800"/>
+              <a:t>•  Unique Feature 4: Automated Penalty &amp; Deadline Extractor with Calendar Sync.</a:t>
+            </a:r>
+          </a:p>
+          <a:p>
+            <a:pPr>
+              <a:spcAft>
+                <a:spcPts val="700"/>
               </a:spcAft>
               <a:defRPr sz="1250">
                 <a:solidFill>
@@ -9626,7 +9626,22 @@
               </a:defRPr>
             </a:pPr>
             <a:r>
-              <a:t>•  Unique Feature 5: Offline PWA works without active internet connectivity.</a:t>
+              <a:t>•  Unique Feature 5: 100% Strict Student Privacy (Zero credentials stored).</a:t>
+            </a:r>
+          </a:p>
+          <a:p>
+            <a:pPr>
+              <a:spcAft>
+                <a:spcPts val="700"/>
+              </a:spcAft>
+              <a:defRPr sz="1250">
+                <a:solidFill>
+                  <a:srgbClr val="0F172A"/>
+                </a:solidFill>
+              </a:defRPr>
+            </a:pPr>
+            <a:r>
+              <a:t>•  Unique Feature 6: Offline PWA works without active internet connectivity.</a:t>
             </a:r>
           </a:p>
         </p:txBody>
@@ -13127,6 +13142,21 @@
               </a:defRPr>
             </a:pPr>
             <a:r>
+              <a:t>•  Command: /ask &lt;query&gt; ➔ Ask GTU AI natural language Q&amp;A engine.</a:t>
+            </a:r>
+          </a:p>
+          <a:p>
+            <a:pPr>
+              <a:spcAft>
+                <a:spcPts val="1000"/>
+              </a:spcAft>
+              <a:defRPr sz="1250">
+                <a:solidFill>
+                  <a:srgbClr val="0F172A"/>
+                </a:solidFill>
+              </a:defRPr>
+            </a:pPr>
+            <a:r>
               <a:t>•  Command: /latest ➔ Instantly delivers latest 5 circulars with direct PDF links.</a:t>
             </a:r>
           </a:p>
@@ -13157,7 +13187,7 @@
               </a:defRPr>
             </a:pPr>
             <a:r>
-              <a:t>•  Command: /filter &lt;course&gt; ➔ Shows notices tailored to BE, Diploma, or MBA.</a:t>
+              <a:t>•  Command: /subscribe &lt;course&gt; ➔ Tailored stream alerts (BE, Diploma, MBA).</a:t>
             </a:r>
           </a:p>
           <a:p>
@@ -13172,7 +13202,7 @@
               </a:defRPr>
             </a:pPr>
             <a:r>
-              <a:t>•  Command: /summary ➔ Delivers AI-generated 1-minute briefing of today's circulars.</a:t>
+              <a:t>•  Command: /voice ➔ Sends 30-second audio news podcast directly in chat.</a:t>
             </a:r>
           </a:p>
           <a:p>
@@ -13187,22 +13217,7 @@
               </a:defRPr>
             </a:pPr>
             <a:r>
-              <a:t>•  Command: /voice ➔ Sends 30-second audio news podcast directly in chat.</a:t>
-            </a:r>
-          </a:p>
-          <a:p>
-            <a:pPr>
-              <a:spcAft>
-                <a:spcPts val="1000"/>
-              </a:spcAft>
-              <a:defRPr sz="1250">
-                <a:solidFill>
-                  <a:srgbClr val="0F172A"/>
-                </a:solidFill>
-              </a:defRPr>
-            </a:pPr>
-            <a:r>
-              <a:t>•  Demonstrates sub-second response time and zero user registration friction.</a:t>
+              <a:t>•  Sub-second response time and zero user registration friction.</a:t>
             </a:r>
           </a:p>
           <a:p>
@@ -13390,22 +13405,22 @@
               </a:defRPr>
             </a:pPr>
             <a:r>
+              <a:t>•  ✨ Ask GTU AI Assistant: Interactive Q&amp;A bar with instant citations &amp; +Cal sync.</a:t>
+            </a:r>
+          </a:p>
+          <a:p>
+            <a:pPr>
+              <a:spcAft>
+                <a:spcPts val="1000"/>
+              </a:spcAft>
+              <a:defRPr sz="1250">
+                <a:solidFill>
+                  <a:srgbClr val="0F172A"/>
+                </a:solidFill>
+              </a:defRPr>
+            </a:pPr>
+            <a:r>
               <a:t>•  Interactive Dashboard: Live search, stream dropdowns, date sorting.</a:t>
-            </a:r>
-          </a:p>
-          <a:p>
-            <a:pPr>
-              <a:spcAft>
-                <a:spcPts val="1000"/>
-              </a:spcAft>
-              <a:defRPr sz="1250">
-                <a:solidFill>
-                  <a:srgbClr val="0F172A"/>
-                </a:solidFill>
-              </a:defRPr>
-            </a:pPr>
-            <a:r>
-              <a:t>•  Dark &amp; Light Mode: Clean glassmorphism styling with persistent state.</a:t>
             </a:r>
           </a:p>
           <a:p>

</xml_diff>